<commit_message>
refactor: pre-scale KP template instead of runtime regex scaling
Replace the fragile runtime ×0.5 regex-based scaling with a pre-processed
template file. The commercial_template.pptx is now already at 10×5.63"
(matching base templates) with:
- All positions, sizes, fonts, margins, spacing scaled by 0.5
- -apple-system font replaced with Arial
- ИТОГО/footer labels: wrap=none, noAutofit, widened text boxes
- Title box widened to 65% slide width

This eliminates scaleSlideXml() and all runtime regex transformations,
removing 82 lines of brittle code. The JS now only fills data into
shapes and handles adaptive layout.

Co-Authored-By: Claude Opus 4.6 <noreply@anthropic.com>
</commit_message>
<xml_diff>
--- a/public/templates/commercial_template.pptx
+++ b/public/templates/commercial_template.pptx
@@ -10,8 +10,8 @@
   <p:sldIdLst>
     <p:sldId id="258" r:id="rId2"/>
   </p:sldIdLst>
-  <p:sldSz cx="18288000" cy="10287000"/>
-  <p:notesSz cx="10287000" cy="18288000"/>
+  <p:sldSz cx="9144000" cy="5143500"/>
+  <p:notesSz cx="5143500" cy="9144000"/>
   <p:defaultTextStyle>
     <a:lvl1pPr marL="0" algn="l" defTabSz="914400" rtl="0" eaLnBrk="1" latinLnBrk="0" hangingPunct="1">
       <a:defRPr sz="1800" kern="1200">
@@ -666,18 +666,18 @@
         </p:nvSpPr>
         <p:spPr>
           <a:xfrm>
-            <a:off x="952500" y="719286"/>
-            <a:ext cx="7479700" cy="659829"/>
-          </a:xfrm>
-          <a:prstGeom prst="rect">
-            <a:avLst/>
-          </a:prstGeom>
-          <a:noFill/>
-          <a:ln/>
-        </p:spPr>
-        <p:txBody>
-          <a:bodyPr wrap="square" lIns="25400" tIns="25400" rIns="25400" bIns="25400" rtlCol="0" anchor="t">
-            <a:normAutofit/>
+            <a:off x="476250" y="359643"/>
+            <a:ext cx="5943600" cy="329914"/>
+          </a:xfrm>
+          <a:prstGeom prst="rect">
+            <a:avLst/>
+          </a:prstGeom>
+          <a:noFill/>
+          <a:ln/>
+        </p:spPr>
+        <p:txBody>
+          <a:bodyPr wrap="none" lIns="12700" tIns="12700" rIns="12700" bIns="12700" rtlCol="0" anchor="t">
+            <a:noAutofit/>
           </a:bodyPr>
           <a:lstStyle/>
           <a:p>
@@ -688,28 +688,28 @@
               <a:buNone/>
             </a:pPr>
             <a:r>
-              <a:rPr lang="en-US" sz="4800" b="1" kern="0" spc="-48" dirty="0">
+              <a:rPr lang="en-US" sz="2400" b="1" kern="0" spc="-24" dirty="0">
                 <a:solidFill>
                   <a:srgbClr val="0B1F3A"/>
                 </a:solidFill>
-                <a:latin typeface="-apple-system" pitchFamily="34" charset="0"/>
-                <a:ea typeface="-apple-system" pitchFamily="34" charset="-122"/>
-                <a:cs typeface="-apple-system" pitchFamily="34" charset="-120"/>
-              </a:rPr>
-              <a:t>Детализация </a:t>
-            </a:r>
-            <a:r>
-              <a:rPr lang="en-US" sz="4800" b="1" kern="0" spc="-48" dirty="0">
+                <a:latin typeface="Arial" pitchFamily="34" charset="0"/>
+                <a:ea typeface="Arial" pitchFamily="34" charset="-122"/>
+                <a:cs typeface="Arial" pitchFamily="34" charset="-120"/>
+              </a:rPr>
+              <a:t xml:space="preserve">Детализация </a:t>
+            </a:r>
+            <a:r>
+              <a:rPr lang="en-US" sz="2400" b="1" kern="0" spc="-24" dirty="0">
                 <a:solidFill>
                   <a:srgbClr val="FF6A1A"/>
                 </a:solidFill>
-                <a:latin typeface="-apple-system" pitchFamily="34" charset="0"/>
-                <a:ea typeface="-apple-system" pitchFamily="34" charset="-122"/>
-                <a:cs typeface="-apple-system" pitchFamily="34" charset="-120"/>
+                <a:latin typeface="Arial" pitchFamily="34" charset="0"/>
+                <a:ea typeface="Arial" pitchFamily="34" charset="-122"/>
+                <a:cs typeface="Arial" pitchFamily="34" charset="-120"/>
               </a:rPr>
               <a:t>стоимости</a:t>
             </a:r>
-            <a:endParaRPr lang="en-US" sz="4800" dirty="0"/>
+            <a:endParaRPr lang="en-US" sz="2400" dirty="0"/>
           </a:p>
         </p:txBody>
       </p:sp>
@@ -721,18 +721,18 @@
         </p:nvSpPr>
         <p:spPr>
           <a:xfrm>
-            <a:off x="15143485" y="685800"/>
-            <a:ext cx="2192015" cy="372368"/>
-          </a:xfrm>
-          <a:prstGeom prst="rect">
-            <a:avLst/>
-          </a:prstGeom>
-          <a:noFill/>
-          <a:ln/>
-        </p:spPr>
-        <p:txBody>
-          <a:bodyPr wrap="square" lIns="25400" tIns="25400" rIns="25400" bIns="25400" rtlCol="0" anchor="t">
-            <a:normAutofit/>
+            <a:off x="7571742" y="342900"/>
+            <a:ext cx="1096008" cy="186184"/>
+          </a:xfrm>
+          <a:prstGeom prst="rect">
+            <a:avLst/>
+          </a:prstGeom>
+          <a:noFill/>
+          <a:ln/>
+        </p:spPr>
+        <p:txBody>
+          <a:bodyPr wrap="none" lIns="12700" tIns="12700" rIns="12700" bIns="12700" rtlCol="0" anchor="t">
+            <a:noAutofit/>
           </a:bodyPr>
           <a:lstStyle/>
           <a:p>
@@ -743,17 +743,17 @@
               <a:buNone/>
             </a:pPr>
             <a:r>
-              <a:rPr lang="en-US" sz="1950" b="1" dirty="0">
+              <a:rPr lang="en-US" sz="975" b="1" dirty="0">
                 <a:solidFill>
                   <a:srgbClr val="0B1F3A"/>
                 </a:solidFill>
-                <a:latin typeface="-apple-system" pitchFamily="34" charset="0"/>
-                <a:ea typeface="-apple-system" pitchFamily="34" charset="-122"/>
-                <a:cs typeface="-apple-system" pitchFamily="34" charset="-120"/>
+                <a:latin typeface="Arial" pitchFamily="34" charset="0"/>
+                <a:ea typeface="Arial" pitchFamily="34" charset="-122"/>
+                <a:cs typeface="Arial" pitchFamily="34" charset="-120"/>
               </a:rPr>
               <a:t>Тимирязев центр</a:t>
             </a:r>
-            <a:endParaRPr lang="en-US" sz="1950" dirty="0"/>
+            <a:endParaRPr lang="en-US" sz="975" dirty="0"/>
           </a:p>
         </p:txBody>
       </p:sp>
@@ -765,18 +765,18 @@
         </p:nvSpPr>
         <p:spPr>
           <a:xfrm>
-            <a:off x="15591755" y="1072455"/>
-            <a:ext cx="1819945" cy="285750"/>
-          </a:xfrm>
-          <a:prstGeom prst="rect">
-            <a:avLst/>
-          </a:prstGeom>
-          <a:noFill/>
-          <a:ln/>
-        </p:spPr>
-        <p:txBody>
-          <a:bodyPr wrap="square" lIns="0" tIns="0" rIns="0" bIns="0" rtlCol="0" anchor="t">
-            <a:normAutofit/>
+            <a:off x="7795878" y="536228"/>
+            <a:ext cx="909972" cy="142875"/>
+          </a:xfrm>
+          <a:prstGeom prst="rect">
+            <a:avLst/>
+          </a:prstGeom>
+          <a:noFill/>
+          <a:ln/>
+        </p:spPr>
+        <p:txBody>
+          <a:bodyPr wrap="none" lIns="0" tIns="0" rIns="0" bIns="0" rtlCol="0" anchor="t">
+            <a:noAutofit/>
           </a:bodyPr>
           <a:lstStyle/>
           <a:p>
@@ -787,17 +787,17 @@
               <a:buNone/>
             </a:pPr>
             <a:r>
-              <a:rPr lang="en-US" sz="1650" dirty="0">
+              <a:rPr lang="en-US" sz="825" dirty="0">
                 <a:solidFill>
                   <a:srgbClr val="6A7285"/>
                 </a:solidFill>
-                <a:latin typeface="-apple-system" pitchFamily="34" charset="0"/>
-                <a:ea typeface="-apple-system" pitchFamily="34" charset="-122"/>
-                <a:cs typeface="-apple-system" pitchFamily="34" charset="-120"/>
+                <a:latin typeface="Arial" pitchFamily="34" charset="0"/>
+                <a:ea typeface="Arial" pitchFamily="34" charset="-122"/>
+                <a:cs typeface="Arial" pitchFamily="34" charset="-120"/>
               </a:rPr>
               <a:t>21 апреля 2026 г.</a:t>
             </a:r>
-            <a:endParaRPr lang="en-US" sz="1650" dirty="0"/>
+            <a:endParaRPr lang="en-US" sz="825" dirty="0"/>
           </a:p>
         </p:txBody>
       </p:sp>
@@ -809,8 +809,8 @@
         </p:nvSpPr>
         <p:spPr>
           <a:xfrm>
-            <a:off x="952500" y="1683916"/>
-            <a:ext cx="8086725" cy="6555209"/>
+            <a:off x="476250" y="841958"/>
+            <a:ext cx="4043362" cy="3277604"/>
           </a:xfrm>
           <a:prstGeom prst="roundRect">
             <a:avLst>
@@ -838,17 +838,17 @@
         </p:nvSpPr>
         <p:spPr>
           <a:xfrm>
-            <a:off x="1257300" y="1931566"/>
-            <a:ext cx="7701439" cy="304800"/>
-          </a:xfrm>
-          <a:prstGeom prst="rect">
-            <a:avLst/>
-          </a:prstGeom>
-          <a:noFill/>
-          <a:ln/>
-        </p:spPr>
-        <p:txBody>
-          <a:bodyPr wrap="square" lIns="25400" tIns="25400" rIns="25400" bIns="25400" rtlCol="0" anchor="ctr">
+            <a:off x="628650" y="965783"/>
+            <a:ext cx="3850720" cy="152400"/>
+          </a:xfrm>
+          <a:prstGeom prst="rect">
+            <a:avLst/>
+          </a:prstGeom>
+          <a:noFill/>
+          <a:ln/>
+        </p:spPr>
+        <p:txBody>
+          <a:bodyPr wrap="square" lIns="12700" tIns="12700" rIns="12700" bIns="12700" rtlCol="0" anchor="ctr">
             <a:normAutofit/>
           </a:bodyPr>
           <a:lstStyle/>
@@ -857,17 +857,17 @@
               <a:buNone/>
             </a:pPr>
             <a:r>
-              <a:rPr lang="en-US" sz="1800" b="1" kern="0" spc="-9" dirty="0">
+              <a:rPr lang="en-US" sz="900" b="1" kern="0" spc="-4" dirty="0">
                 <a:solidFill>
                   <a:srgbClr val="0B1F3A"/>
                 </a:solidFill>
-                <a:latin typeface="-apple-system" pitchFamily="34" charset="0"/>
-                <a:ea typeface="-apple-system" pitchFamily="34" charset="-122"/>
-                <a:cs typeface="-apple-system" pitchFamily="34" charset="-120"/>
+                <a:latin typeface="Arial" pitchFamily="34" charset="0"/>
+                <a:ea typeface="Arial" pitchFamily="34" charset="-122"/>
+                <a:cs typeface="Arial" pitchFamily="34" charset="-120"/>
               </a:rPr>
               <a:t>Оборудование</a:t>
             </a:r>
-            <a:endParaRPr lang="en-US" sz="1800" dirty="0"/>
+            <a:endParaRPr lang="en-US" sz="900" dirty="0"/>
           </a:p>
         </p:txBody>
       </p:sp>
@@ -879,8 +879,8 @@
         </p:nvSpPr>
         <p:spPr>
           <a:xfrm>
-            <a:off x="1257300" y="2646387"/>
-            <a:ext cx="3289920" cy="9525"/>
+            <a:off x="628650" y="1323194"/>
+            <a:ext cx="1644960" cy="4762"/>
           </a:xfrm>
           <a:prstGeom prst="rect">
             <a:avLst/>
@@ -899,17 +899,17 @@
         </p:nvSpPr>
         <p:spPr>
           <a:xfrm>
-            <a:off x="1333500" y="2388766"/>
-            <a:ext cx="3236218" cy="200471"/>
-          </a:xfrm>
-          <a:prstGeom prst="rect">
-            <a:avLst/>
-          </a:prstGeom>
-          <a:noFill/>
-          <a:ln/>
-        </p:spPr>
-        <p:txBody>
-          <a:bodyPr wrap="square" lIns="25400" tIns="25400" rIns="25400" bIns="25400" rtlCol="0" anchor="ctr">
+            <a:off x="666750" y="1194383"/>
+            <a:ext cx="1618109" cy="100236"/>
+          </a:xfrm>
+          <a:prstGeom prst="rect">
+            <a:avLst/>
+          </a:prstGeom>
+          <a:noFill/>
+          <a:ln/>
+        </p:spPr>
+        <p:txBody>
+          <a:bodyPr wrap="square" lIns="12700" tIns="12700" rIns="12700" bIns="12700" rtlCol="0" anchor="ctr">
             <a:normAutofit/>
           </a:bodyPr>
           <a:lstStyle/>
@@ -921,17 +921,17 @@
               <a:buNone/>
             </a:pPr>
             <a:r>
-              <a:rPr lang="en-US" sz="975" b="1" kern="0" spc="78" dirty="0">
+              <a:rPr lang="en-US" sz="488" b="1" kern="0" spc="39" dirty="0">
                 <a:solidFill>
                   <a:srgbClr val="6A7285"/>
                 </a:solidFill>
-                <a:latin typeface="-apple-system" pitchFamily="34" charset="0"/>
-                <a:ea typeface="-apple-system" pitchFamily="34" charset="-122"/>
-                <a:cs typeface="-apple-system" pitchFamily="34" charset="-120"/>
+                <a:latin typeface="Arial" pitchFamily="34" charset="0"/>
+                <a:ea typeface="Arial" pitchFamily="34" charset="-122"/>
+                <a:cs typeface="Arial" pitchFamily="34" charset="-120"/>
               </a:rPr>
               <a:t>НАИМЕНОВАНИЕ</a:t>
             </a:r>
-            <a:endParaRPr lang="en-US" sz="975" dirty="0"/>
+            <a:endParaRPr lang="en-US" sz="488" dirty="0"/>
           </a:p>
         </p:txBody>
       </p:sp>
@@ -943,8 +943,8 @@
         </p:nvSpPr>
         <p:spPr>
           <a:xfrm>
-            <a:off x="4547220" y="2646387"/>
-            <a:ext cx="717724" cy="9525"/>
+            <a:off x="2273610" y="1323194"/>
+            <a:ext cx="358862" cy="4762"/>
           </a:xfrm>
           <a:prstGeom prst="rect">
             <a:avLst/>
@@ -963,17 +963,17 @@
         </p:nvSpPr>
         <p:spPr>
           <a:xfrm>
-            <a:off x="4547220" y="2388766"/>
-            <a:ext cx="641524" cy="200471"/>
-          </a:xfrm>
-          <a:prstGeom prst="rect">
-            <a:avLst/>
-          </a:prstGeom>
-          <a:noFill/>
-          <a:ln/>
-        </p:spPr>
-        <p:txBody>
-          <a:bodyPr wrap="square" lIns="25400" tIns="25400" rIns="25400" bIns="25400" rtlCol="0" anchor="ctr">
+            <a:off x="2273610" y="1194383"/>
+            <a:ext cx="320762" cy="100236"/>
+          </a:xfrm>
+          <a:prstGeom prst="rect">
+            <a:avLst/>
+          </a:prstGeom>
+          <a:noFill/>
+          <a:ln/>
+        </p:spPr>
+        <p:txBody>
+          <a:bodyPr wrap="square" lIns="12700" tIns="12700" rIns="12700" bIns="12700" rtlCol="0" anchor="ctr">
             <a:normAutofit/>
           </a:bodyPr>
           <a:lstStyle/>
@@ -985,17 +985,17 @@
               <a:buNone/>
             </a:pPr>
             <a:r>
-              <a:rPr lang="en-US" sz="975" b="1" kern="0" spc="78" dirty="0">
+              <a:rPr lang="en-US" sz="488" b="1" kern="0" spc="39" dirty="0">
                 <a:solidFill>
                   <a:srgbClr val="6A7285"/>
                 </a:solidFill>
-                <a:latin typeface="-apple-system" pitchFamily="34" charset="0"/>
-                <a:ea typeface="-apple-system" pitchFamily="34" charset="-122"/>
-                <a:cs typeface="-apple-system" pitchFamily="34" charset="-120"/>
+                <a:latin typeface="Arial" pitchFamily="34" charset="0"/>
+                <a:ea typeface="Arial" pitchFamily="34" charset="-122"/>
+                <a:cs typeface="Arial" pitchFamily="34" charset="-120"/>
               </a:rPr>
               <a:t>КОЛ.</a:t>
             </a:r>
-            <a:endParaRPr lang="en-US" sz="975" dirty="0"/>
+            <a:endParaRPr lang="en-US" sz="488" dirty="0"/>
           </a:p>
         </p:txBody>
       </p:sp>
@@ -1007,8 +1007,8 @@
         </p:nvSpPr>
         <p:spPr>
           <a:xfrm>
-            <a:off x="5264944" y="2646387"/>
-            <a:ext cx="1185863" cy="9525"/>
+            <a:off x="2632472" y="1323194"/>
+            <a:ext cx="592932" cy="4762"/>
           </a:xfrm>
           <a:prstGeom prst="rect">
             <a:avLst/>
@@ -1027,17 +1027,17 @@
         </p:nvSpPr>
         <p:spPr>
           <a:xfrm>
-            <a:off x="5264944" y="2388766"/>
-            <a:ext cx="1109662" cy="200471"/>
-          </a:xfrm>
-          <a:prstGeom prst="rect">
-            <a:avLst/>
-          </a:prstGeom>
-          <a:noFill/>
-          <a:ln/>
-        </p:spPr>
-        <p:txBody>
-          <a:bodyPr wrap="square" lIns="25400" tIns="25400" rIns="25400" bIns="25400" rtlCol="0" anchor="ctr">
+            <a:off x="2632472" y="1194383"/>
+            <a:ext cx="554831" cy="100236"/>
+          </a:xfrm>
+          <a:prstGeom prst="rect">
+            <a:avLst/>
+          </a:prstGeom>
+          <a:noFill/>
+          <a:ln/>
+        </p:spPr>
+        <p:txBody>
+          <a:bodyPr wrap="square" lIns="12700" tIns="12700" rIns="12700" bIns="12700" rtlCol="0" anchor="ctr">
             <a:normAutofit/>
           </a:bodyPr>
           <a:lstStyle/>
@@ -1049,17 +1049,17 @@
               <a:buNone/>
             </a:pPr>
             <a:r>
-              <a:rPr lang="en-US" sz="975" b="1" kern="0" spc="78" dirty="0">
+              <a:rPr lang="en-US" sz="488" b="1" kern="0" spc="39" dirty="0">
                 <a:solidFill>
                   <a:srgbClr val="6A7285"/>
                 </a:solidFill>
-                <a:latin typeface="-apple-system" pitchFamily="34" charset="0"/>
-                <a:ea typeface="-apple-system" pitchFamily="34" charset="-122"/>
-                <a:cs typeface="-apple-system" pitchFamily="34" charset="-120"/>
+                <a:latin typeface="Arial" pitchFamily="34" charset="0"/>
+                <a:ea typeface="Arial" pitchFamily="34" charset="-122"/>
+                <a:cs typeface="Arial" pitchFamily="34" charset="-120"/>
               </a:rPr>
               <a:t>ЦЕНА</a:t>
             </a:r>
-            <a:endParaRPr lang="en-US" sz="975" dirty="0"/>
+            <a:endParaRPr lang="en-US" sz="488" dirty="0"/>
           </a:p>
         </p:txBody>
       </p:sp>
@@ -1071,8 +1071,8 @@
         </p:nvSpPr>
         <p:spPr>
           <a:xfrm>
-            <a:off x="6450806" y="2646387"/>
-            <a:ext cx="910010" cy="9525"/>
+            <a:off x="3225403" y="1323194"/>
+            <a:ext cx="455005" cy="4762"/>
           </a:xfrm>
           <a:prstGeom prst="rect">
             <a:avLst/>
@@ -1091,17 +1091,17 @@
         </p:nvSpPr>
         <p:spPr>
           <a:xfrm>
-            <a:off x="6450806" y="2388766"/>
-            <a:ext cx="833810" cy="200471"/>
-          </a:xfrm>
-          <a:prstGeom prst="rect">
-            <a:avLst/>
-          </a:prstGeom>
-          <a:noFill/>
-          <a:ln/>
-        </p:spPr>
-        <p:txBody>
-          <a:bodyPr wrap="square" lIns="25400" tIns="25400" rIns="25400" bIns="25400" rtlCol="0" anchor="ctr">
+            <a:off x="3225403" y="1194383"/>
+            <a:ext cx="416905" cy="100236"/>
+          </a:xfrm>
+          <a:prstGeom prst="rect">
+            <a:avLst/>
+          </a:prstGeom>
+          <a:noFill/>
+          <a:ln/>
+        </p:spPr>
+        <p:txBody>
+          <a:bodyPr wrap="square" lIns="12700" tIns="12700" rIns="12700" bIns="12700" rtlCol="0" anchor="ctr">
             <a:normAutofit/>
           </a:bodyPr>
           <a:lstStyle/>
@@ -1113,17 +1113,17 @@
               <a:buNone/>
             </a:pPr>
             <a:r>
-              <a:rPr lang="en-US" sz="975" b="1" kern="0" spc="78" dirty="0">
+              <a:rPr lang="en-US" sz="488" b="1" kern="0" spc="39" dirty="0">
                 <a:solidFill>
                   <a:srgbClr val="6A7285"/>
                 </a:solidFill>
-                <a:latin typeface="-apple-system" pitchFamily="34" charset="0"/>
-                <a:ea typeface="-apple-system" pitchFamily="34" charset="-122"/>
-                <a:cs typeface="-apple-system" pitchFamily="34" charset="-120"/>
+                <a:latin typeface="Arial" pitchFamily="34" charset="0"/>
+                <a:ea typeface="Arial" pitchFamily="34" charset="-122"/>
+                <a:cs typeface="Arial" pitchFamily="34" charset="-120"/>
               </a:rPr>
               <a:t>СКИДКА</a:t>
             </a:r>
-            <a:endParaRPr lang="en-US" sz="975" dirty="0"/>
+            <a:endParaRPr lang="en-US" sz="488" dirty="0"/>
           </a:p>
         </p:txBody>
       </p:sp>
@@ -1135,8 +1135,8 @@
         </p:nvSpPr>
         <p:spPr>
           <a:xfrm>
-            <a:off x="7360816" y="2646387"/>
-            <a:ext cx="1373609" cy="9525"/>
+            <a:off x="3680408" y="1323194"/>
+            <a:ext cx="686804" cy="4762"/>
           </a:xfrm>
           <a:prstGeom prst="rect">
             <a:avLst/>
@@ -1155,17 +1155,17 @@
         </p:nvSpPr>
         <p:spPr>
           <a:xfrm>
-            <a:off x="7360816" y="2388766"/>
-            <a:ext cx="1297409" cy="200471"/>
-          </a:xfrm>
-          <a:prstGeom prst="rect">
-            <a:avLst/>
-          </a:prstGeom>
-          <a:noFill/>
-          <a:ln/>
-        </p:spPr>
-        <p:txBody>
-          <a:bodyPr wrap="square" lIns="25400" tIns="25400" rIns="25400" bIns="25400" rtlCol="0" anchor="ctr">
+            <a:off x="3680408" y="1194383"/>
+            <a:ext cx="648704" cy="100236"/>
+          </a:xfrm>
+          <a:prstGeom prst="rect">
+            <a:avLst/>
+          </a:prstGeom>
+          <a:noFill/>
+          <a:ln/>
+        </p:spPr>
+        <p:txBody>
+          <a:bodyPr wrap="square" lIns="12700" tIns="12700" rIns="12700" bIns="12700" rtlCol="0" anchor="ctr">
             <a:normAutofit/>
           </a:bodyPr>
           <a:lstStyle/>
@@ -1177,17 +1177,17 @@
               <a:buNone/>
             </a:pPr>
             <a:r>
-              <a:rPr lang="en-US" sz="975" b="1" kern="0" spc="78" dirty="0">
+              <a:rPr lang="en-US" sz="488" b="1" kern="0" spc="39" dirty="0">
                 <a:solidFill>
                   <a:srgbClr val="6A7285"/>
                 </a:solidFill>
-                <a:latin typeface="-apple-system" pitchFamily="34" charset="0"/>
-                <a:ea typeface="-apple-system" pitchFamily="34" charset="-122"/>
-                <a:cs typeface="-apple-system" pitchFamily="34" charset="-120"/>
+                <a:latin typeface="Arial" pitchFamily="34" charset="0"/>
+                <a:ea typeface="Arial" pitchFamily="34" charset="-122"/>
+                <a:cs typeface="Arial" pitchFamily="34" charset="-120"/>
               </a:rPr>
               <a:t>СУММА</a:t>
             </a:r>
-            <a:endParaRPr lang="en-US" sz="975" dirty="0"/>
+            <a:endParaRPr lang="en-US" sz="488" dirty="0"/>
           </a:p>
         </p:txBody>
       </p:sp>
@@ -1199,8 +1199,8 @@
         </p:nvSpPr>
         <p:spPr>
           <a:xfrm>
-            <a:off x="1257300" y="3084016"/>
-            <a:ext cx="3289920" cy="9525"/>
+            <a:off x="628650" y="1542008"/>
+            <a:ext cx="1644960" cy="4762"/>
           </a:xfrm>
           <a:prstGeom prst="rect">
             <a:avLst/>
@@ -1219,17 +1219,17 @@
         </p:nvSpPr>
         <p:spPr>
           <a:xfrm>
-            <a:off x="1333500" y="2760687"/>
-            <a:ext cx="3236218" cy="256654"/>
-          </a:xfrm>
-          <a:prstGeom prst="rect">
-            <a:avLst/>
-          </a:prstGeom>
-          <a:noFill/>
-          <a:ln/>
-        </p:spPr>
-        <p:txBody>
-          <a:bodyPr wrap="square" lIns="25400" tIns="25400" rIns="25400" bIns="25400" rtlCol="0" anchor="ctr">
+            <a:off x="666750" y="1380344"/>
+            <a:ext cx="1618109" cy="128327"/>
+          </a:xfrm>
+          <a:prstGeom prst="rect">
+            <a:avLst/>
+          </a:prstGeom>
+          <a:noFill/>
+          <a:ln/>
+        </p:spPr>
+        <p:txBody>
+          <a:bodyPr wrap="square" lIns="12700" tIns="12700" rIns="12700" bIns="12700" rtlCol="0" anchor="ctr">
             <a:normAutofit/>
           </a:bodyPr>
           <a:lstStyle/>
@@ -1241,17 +1241,17 @@
               <a:buNone/>
             </a:pPr>
             <a:r>
-              <a:rPr lang="en-US" sz="1275" b="1" dirty="0">
+              <a:rPr lang="en-US" sz="638" b="1" dirty="0">
                 <a:solidFill>
                   <a:srgbClr val="0B1F3A"/>
                 </a:solidFill>
-                <a:latin typeface="-apple-system" pitchFamily="34" charset="0"/>
-                <a:ea typeface="-apple-system" pitchFamily="34" charset="-122"/>
-                <a:cs typeface="-apple-system" pitchFamily="34" charset="-120"/>
+                <a:latin typeface="Arial" pitchFamily="34" charset="0"/>
+                <a:ea typeface="Arial" pitchFamily="34" charset="-122"/>
+                <a:cs typeface="Arial" pitchFamily="34" charset="-120"/>
               </a:rPr>
               <a:t>Настольный КСО, 21,5″</a:t>
             </a:r>
-            <a:endParaRPr lang="en-US" sz="1275" dirty="0"/>
+            <a:endParaRPr lang="en-US" sz="638" dirty="0"/>
           </a:p>
         </p:txBody>
       </p:sp>
@@ -1263,8 +1263,8 @@
         </p:nvSpPr>
         <p:spPr>
           <a:xfrm>
-            <a:off x="4547220" y="3084016"/>
-            <a:ext cx="717724" cy="9525"/>
+            <a:off x="2273610" y="1542008"/>
+            <a:ext cx="358862" cy="4762"/>
           </a:xfrm>
           <a:prstGeom prst="rect">
             <a:avLst/>
@@ -1283,17 +1283,17 @@
         </p:nvSpPr>
         <p:spPr>
           <a:xfrm>
-            <a:off x="4547220" y="2760687"/>
-            <a:ext cx="641524" cy="256654"/>
-          </a:xfrm>
-          <a:prstGeom prst="rect">
-            <a:avLst/>
-          </a:prstGeom>
-          <a:noFill/>
-          <a:ln/>
-        </p:spPr>
-        <p:txBody>
-          <a:bodyPr wrap="square" lIns="25400" tIns="25400" rIns="25400" bIns="25400" rtlCol="0" anchor="ctr">
+            <a:off x="2273610" y="1380344"/>
+            <a:ext cx="320762" cy="128327"/>
+          </a:xfrm>
+          <a:prstGeom prst="rect">
+            <a:avLst/>
+          </a:prstGeom>
+          <a:noFill/>
+          <a:ln/>
+        </p:spPr>
+        <p:txBody>
+          <a:bodyPr wrap="square" lIns="12700" tIns="12700" rIns="12700" bIns="12700" rtlCol="0" anchor="ctr">
             <a:normAutofit/>
           </a:bodyPr>
           <a:lstStyle/>
@@ -1305,7 +1305,7 @@
               <a:buNone/>
             </a:pPr>
             <a:r>
-              <a:rPr lang="en-US" sz="1163" kern="0" spc="-12" dirty="0">
+              <a:rPr lang="en-US" sz="582" kern="0" spc="-6" dirty="0">
                 <a:solidFill>
                   <a:srgbClr val="29334A"/>
                 </a:solidFill>
@@ -1315,7 +1315,7 @@
               </a:rPr>
               <a:t>5</a:t>
             </a:r>
-            <a:endParaRPr lang="en-US" sz="1163" dirty="0"/>
+            <a:endParaRPr lang="en-US" sz="582" dirty="0"/>
           </a:p>
         </p:txBody>
       </p:sp>
@@ -1327,8 +1327,8 @@
         </p:nvSpPr>
         <p:spPr>
           <a:xfrm>
-            <a:off x="5264944" y="3084016"/>
-            <a:ext cx="1185863" cy="9525"/>
+            <a:off x="2632472" y="1542008"/>
+            <a:ext cx="592932" cy="4762"/>
           </a:xfrm>
           <a:prstGeom prst="rect">
             <a:avLst/>
@@ -1347,17 +1347,17 @@
         </p:nvSpPr>
         <p:spPr>
           <a:xfrm>
-            <a:off x="5264944" y="2760687"/>
-            <a:ext cx="1109662" cy="256654"/>
-          </a:xfrm>
-          <a:prstGeom prst="rect">
-            <a:avLst/>
-          </a:prstGeom>
-          <a:noFill/>
-          <a:ln/>
-        </p:spPr>
-        <p:txBody>
-          <a:bodyPr wrap="square" lIns="25400" tIns="25400" rIns="25400" bIns="25400" rtlCol="0" anchor="ctr">
+            <a:off x="2632472" y="1380344"/>
+            <a:ext cx="554831" cy="128327"/>
+          </a:xfrm>
+          <a:prstGeom prst="rect">
+            <a:avLst/>
+          </a:prstGeom>
+          <a:noFill/>
+          <a:ln/>
+        </p:spPr>
+        <p:txBody>
+          <a:bodyPr wrap="square" lIns="12700" tIns="12700" rIns="12700" bIns="12700" rtlCol="0" anchor="ctr">
             <a:normAutofit/>
           </a:bodyPr>
           <a:lstStyle/>
@@ -1369,7 +1369,7 @@
               <a:buNone/>
             </a:pPr>
             <a:r>
-              <a:rPr lang="en-US" sz="1163" kern="0" spc="-12" dirty="0">
+              <a:rPr lang="en-US" sz="582" kern="0" spc="-6" dirty="0">
                 <a:solidFill>
                   <a:srgbClr val="29334A"/>
                 </a:solidFill>
@@ -1379,7 +1379,7 @@
               </a:rPr>
               <a:t>106 000</a:t>
             </a:r>
-            <a:endParaRPr lang="en-US" sz="1163" dirty="0"/>
+            <a:endParaRPr lang="en-US" sz="582" dirty="0"/>
           </a:p>
         </p:txBody>
       </p:sp>
@@ -1391,8 +1391,8 @@
         </p:nvSpPr>
         <p:spPr>
           <a:xfrm>
-            <a:off x="6450806" y="3084016"/>
-            <a:ext cx="910010" cy="9525"/>
+            <a:off x="3225403" y="1542008"/>
+            <a:ext cx="455005" cy="4762"/>
           </a:xfrm>
           <a:prstGeom prst="rect">
             <a:avLst/>
@@ -1411,17 +1411,17 @@
         </p:nvSpPr>
         <p:spPr>
           <a:xfrm>
-            <a:off x="6450806" y="2760687"/>
-            <a:ext cx="833810" cy="256654"/>
-          </a:xfrm>
-          <a:prstGeom prst="rect">
-            <a:avLst/>
-          </a:prstGeom>
-          <a:noFill/>
-          <a:ln/>
-        </p:spPr>
-        <p:txBody>
-          <a:bodyPr wrap="square" lIns="25400" tIns="25400" rIns="25400" bIns="25400" rtlCol="0" anchor="ctr">
+            <a:off x="3225403" y="1380344"/>
+            <a:ext cx="416905" cy="128327"/>
+          </a:xfrm>
+          <a:prstGeom prst="rect">
+            <a:avLst/>
+          </a:prstGeom>
+          <a:noFill/>
+          <a:ln/>
+        </p:spPr>
+        <p:txBody>
+          <a:bodyPr wrap="square" lIns="12700" tIns="12700" rIns="12700" bIns="12700" rtlCol="0" anchor="ctr">
             <a:normAutofit/>
           </a:bodyPr>
           <a:lstStyle/>
@@ -1433,7 +1433,7 @@
               <a:buNone/>
             </a:pPr>
             <a:r>
-              <a:rPr lang="en-US" sz="1163" b="1" kern="0" spc="-12" dirty="0">
+              <a:rPr lang="en-US" sz="582" b="1" kern="0" spc="-6" dirty="0">
                 <a:solidFill>
                   <a:srgbClr val="FF6A1A"/>
                 </a:solidFill>
@@ -1443,7 +1443,7 @@
               </a:rPr>
               <a:t>-15%</a:t>
             </a:r>
-            <a:endParaRPr lang="en-US" sz="1163" dirty="0"/>
+            <a:endParaRPr lang="en-US" sz="582" dirty="0"/>
           </a:p>
         </p:txBody>
       </p:sp>
@@ -1455,8 +1455,8 @@
         </p:nvSpPr>
         <p:spPr>
           <a:xfrm>
-            <a:off x="7360816" y="3084016"/>
-            <a:ext cx="1373609" cy="9525"/>
+            <a:off x="3680408" y="1542008"/>
+            <a:ext cx="686804" cy="4762"/>
           </a:xfrm>
           <a:prstGeom prst="rect">
             <a:avLst/>
@@ -1475,17 +1475,17 @@
         </p:nvSpPr>
         <p:spPr>
           <a:xfrm>
-            <a:off x="7360816" y="2760687"/>
-            <a:ext cx="1297409" cy="256654"/>
-          </a:xfrm>
-          <a:prstGeom prst="rect">
-            <a:avLst/>
-          </a:prstGeom>
-          <a:noFill/>
-          <a:ln/>
-        </p:spPr>
-        <p:txBody>
-          <a:bodyPr wrap="square" lIns="25400" tIns="25400" rIns="25400" bIns="25400" rtlCol="0" anchor="ctr">
+            <a:off x="3680408" y="1380344"/>
+            <a:ext cx="648704" cy="128327"/>
+          </a:xfrm>
+          <a:prstGeom prst="rect">
+            <a:avLst/>
+          </a:prstGeom>
+          <a:noFill/>
+          <a:ln/>
+        </p:spPr>
+        <p:txBody>
+          <a:bodyPr wrap="square" lIns="12700" tIns="12700" rIns="12700" bIns="12700" rtlCol="0" anchor="ctr">
             <a:normAutofit/>
           </a:bodyPr>
           <a:lstStyle/>
@@ -1497,7 +1497,7 @@
               <a:buNone/>
             </a:pPr>
             <a:r>
-              <a:rPr lang="en-US" sz="1163" b="1" kern="0" spc="-12" dirty="0">
+              <a:rPr lang="en-US" sz="582" b="1" kern="0" spc="-6" dirty="0">
                 <a:solidFill>
                   <a:srgbClr val="0B1F3A"/>
                 </a:solidFill>
@@ -1507,7 +1507,7 @@
               </a:rPr>
               <a:t>450 500</a:t>
             </a:r>
-            <a:endParaRPr lang="en-US" sz="1163" dirty="0"/>
+            <a:endParaRPr lang="en-US" sz="582" dirty="0"/>
           </a:p>
         </p:txBody>
       </p:sp>
@@ -1519,8 +1519,8 @@
         </p:nvSpPr>
         <p:spPr>
           <a:xfrm>
-            <a:off x="1257300" y="3521646"/>
-            <a:ext cx="3289920" cy="9525"/>
+            <a:off x="628650" y="1760823"/>
+            <a:ext cx="1644960" cy="4762"/>
           </a:xfrm>
           <a:prstGeom prst="rect">
             <a:avLst/>
@@ -1539,17 +1539,17 @@
         </p:nvSpPr>
         <p:spPr>
           <a:xfrm>
-            <a:off x="1333500" y="3198316"/>
-            <a:ext cx="3236218" cy="256654"/>
-          </a:xfrm>
-          <a:prstGeom prst="rect">
-            <a:avLst/>
-          </a:prstGeom>
-          <a:noFill/>
-          <a:ln/>
-        </p:spPr>
-        <p:txBody>
-          <a:bodyPr wrap="square" lIns="25400" tIns="25400" rIns="25400" bIns="25400" rtlCol="0" anchor="ctr">
+            <a:off x="666750" y="1599158"/>
+            <a:ext cx="1618109" cy="128327"/>
+          </a:xfrm>
+          <a:prstGeom prst="rect">
+            <a:avLst/>
+          </a:prstGeom>
+          <a:noFill/>
+          <a:ln/>
+        </p:spPr>
+        <p:txBody>
+          <a:bodyPr wrap="square" lIns="12700" tIns="12700" rIns="12700" bIns="12700" rtlCol="0" anchor="ctr">
             <a:normAutofit/>
           </a:bodyPr>
           <a:lstStyle/>
@@ -1561,17 +1561,17 @@
               <a:buNone/>
             </a:pPr>
             <a:r>
-              <a:rPr lang="en-US" sz="1275" b="1" dirty="0">
+              <a:rPr lang="en-US" sz="638" b="1" dirty="0">
                 <a:solidFill>
                   <a:srgbClr val="0B1F3A"/>
                 </a:solidFill>
-                <a:latin typeface="-apple-system" pitchFamily="34" charset="0"/>
-                <a:ea typeface="-apple-system" pitchFamily="34" charset="-122"/>
-                <a:cs typeface="-apple-system" pitchFamily="34" charset="-120"/>
+                <a:latin typeface="Arial" pitchFamily="34" charset="0"/>
+                <a:ea typeface="Arial" pitchFamily="34" charset="-122"/>
+                <a:cs typeface="Arial" pitchFamily="34" charset="-120"/>
               </a:rPr>
               <a:t>Настольный кронштейн для КСО</a:t>
             </a:r>
-            <a:endParaRPr lang="en-US" sz="1275" dirty="0"/>
+            <a:endParaRPr lang="en-US" sz="638" dirty="0"/>
           </a:p>
         </p:txBody>
       </p:sp>
@@ -1583,8 +1583,8 @@
         </p:nvSpPr>
         <p:spPr>
           <a:xfrm>
-            <a:off x="4547220" y="3521646"/>
-            <a:ext cx="717724" cy="9525"/>
+            <a:off x="2273610" y="1760823"/>
+            <a:ext cx="358862" cy="4762"/>
           </a:xfrm>
           <a:prstGeom prst="rect">
             <a:avLst/>
@@ -1603,17 +1603,17 @@
         </p:nvSpPr>
         <p:spPr>
           <a:xfrm>
-            <a:off x="4547220" y="3198316"/>
-            <a:ext cx="641524" cy="256654"/>
-          </a:xfrm>
-          <a:prstGeom prst="rect">
-            <a:avLst/>
-          </a:prstGeom>
-          <a:noFill/>
-          <a:ln/>
-        </p:spPr>
-        <p:txBody>
-          <a:bodyPr wrap="square" lIns="25400" tIns="25400" rIns="25400" bIns="25400" rtlCol="0" anchor="ctr">
+            <a:off x="2273610" y="1599158"/>
+            <a:ext cx="320762" cy="128327"/>
+          </a:xfrm>
+          <a:prstGeom prst="rect">
+            <a:avLst/>
+          </a:prstGeom>
+          <a:noFill/>
+          <a:ln/>
+        </p:spPr>
+        <p:txBody>
+          <a:bodyPr wrap="square" lIns="12700" tIns="12700" rIns="12700" bIns="12700" rtlCol="0" anchor="ctr">
             <a:normAutofit/>
           </a:bodyPr>
           <a:lstStyle/>
@@ -1625,7 +1625,7 @@
               <a:buNone/>
             </a:pPr>
             <a:r>
-              <a:rPr lang="en-US" sz="1163" kern="0" spc="-12" dirty="0">
+              <a:rPr lang="en-US" sz="582" kern="0" spc="-6" dirty="0">
                 <a:solidFill>
                   <a:srgbClr val="29334A"/>
                 </a:solidFill>
@@ -1635,7 +1635,7 @@
               </a:rPr>
               <a:t>5</a:t>
             </a:r>
-            <a:endParaRPr lang="en-US" sz="1163" dirty="0"/>
+            <a:endParaRPr lang="en-US" sz="582" dirty="0"/>
           </a:p>
         </p:txBody>
       </p:sp>
@@ -1647,8 +1647,8 @@
         </p:nvSpPr>
         <p:spPr>
           <a:xfrm>
-            <a:off x="5264944" y="3521646"/>
-            <a:ext cx="1185863" cy="9525"/>
+            <a:off x="2632472" y="1760823"/>
+            <a:ext cx="592932" cy="4762"/>
           </a:xfrm>
           <a:prstGeom prst="rect">
             <a:avLst/>
@@ -1667,17 +1667,17 @@
         </p:nvSpPr>
         <p:spPr>
           <a:xfrm>
-            <a:off x="5264944" y="3198316"/>
-            <a:ext cx="1109662" cy="256654"/>
-          </a:xfrm>
-          <a:prstGeom prst="rect">
-            <a:avLst/>
-          </a:prstGeom>
-          <a:noFill/>
-          <a:ln/>
-        </p:spPr>
-        <p:txBody>
-          <a:bodyPr wrap="square" lIns="25400" tIns="25400" rIns="25400" bIns="25400" rtlCol="0" anchor="ctr">
+            <a:off x="2632472" y="1599158"/>
+            <a:ext cx="554831" cy="128327"/>
+          </a:xfrm>
+          <a:prstGeom prst="rect">
+            <a:avLst/>
+          </a:prstGeom>
+          <a:noFill/>
+          <a:ln/>
+        </p:spPr>
+        <p:txBody>
+          <a:bodyPr wrap="square" lIns="12700" tIns="12700" rIns="12700" bIns="12700" rtlCol="0" anchor="ctr">
             <a:normAutofit/>
           </a:bodyPr>
           <a:lstStyle/>
@@ -1689,7 +1689,7 @@
               <a:buNone/>
             </a:pPr>
             <a:r>
-              <a:rPr lang="en-US" sz="1163" kern="0" spc="-12" dirty="0">
+              <a:rPr lang="en-US" sz="582" kern="0" spc="-6" dirty="0">
                 <a:solidFill>
                   <a:srgbClr val="29334A"/>
                 </a:solidFill>
@@ -1699,7 +1699,7 @@
               </a:rPr>
               <a:t>15 000</a:t>
             </a:r>
-            <a:endParaRPr lang="en-US" sz="1163" dirty="0"/>
+            <a:endParaRPr lang="en-US" sz="582" dirty="0"/>
           </a:p>
         </p:txBody>
       </p:sp>
@@ -1711,8 +1711,8 @@
         </p:nvSpPr>
         <p:spPr>
           <a:xfrm>
-            <a:off x="6450806" y="3521646"/>
-            <a:ext cx="910010" cy="9525"/>
+            <a:off x="3225403" y="1760823"/>
+            <a:ext cx="455005" cy="4762"/>
           </a:xfrm>
           <a:prstGeom prst="rect">
             <a:avLst/>
@@ -1731,17 +1731,17 @@
         </p:nvSpPr>
         <p:spPr>
           <a:xfrm>
-            <a:off x="6450806" y="3198316"/>
-            <a:ext cx="833810" cy="256654"/>
-          </a:xfrm>
-          <a:prstGeom prst="rect">
-            <a:avLst/>
-          </a:prstGeom>
-          <a:noFill/>
-          <a:ln/>
-        </p:spPr>
-        <p:txBody>
-          <a:bodyPr wrap="square" lIns="25400" tIns="25400" rIns="25400" bIns="25400" rtlCol="0" anchor="ctr">
+            <a:off x="3225403" y="1599158"/>
+            <a:ext cx="416905" cy="128327"/>
+          </a:xfrm>
+          <a:prstGeom prst="rect">
+            <a:avLst/>
+          </a:prstGeom>
+          <a:noFill/>
+          <a:ln/>
+        </p:spPr>
+        <p:txBody>
+          <a:bodyPr wrap="square" lIns="12700" tIns="12700" rIns="12700" bIns="12700" rtlCol="0" anchor="ctr">
             <a:normAutofit/>
           </a:bodyPr>
           <a:lstStyle/>
@@ -1753,7 +1753,7 @@
               <a:buNone/>
             </a:pPr>
             <a:r>
-              <a:rPr lang="en-US" sz="1163" kern="0" spc="-12" dirty="0">
+              <a:rPr lang="en-US" sz="582" kern="0" spc="-6" dirty="0">
                 <a:solidFill>
                   <a:srgbClr val="B8BEC9"/>
                 </a:solidFill>
@@ -1763,7 +1763,7 @@
               </a:rPr>
               <a:t>—</a:t>
             </a:r>
-            <a:endParaRPr lang="en-US" sz="1163" dirty="0"/>
+            <a:endParaRPr lang="en-US" sz="582" dirty="0"/>
           </a:p>
         </p:txBody>
       </p:sp>
@@ -1775,8 +1775,8 @@
         </p:nvSpPr>
         <p:spPr>
           <a:xfrm>
-            <a:off x="7360816" y="3521646"/>
-            <a:ext cx="1373609" cy="9525"/>
+            <a:off x="3680408" y="1760823"/>
+            <a:ext cx="686804" cy="4762"/>
           </a:xfrm>
           <a:prstGeom prst="rect">
             <a:avLst/>
@@ -1795,17 +1795,17 @@
         </p:nvSpPr>
         <p:spPr>
           <a:xfrm>
-            <a:off x="7360816" y="3198316"/>
-            <a:ext cx="1297409" cy="256654"/>
-          </a:xfrm>
-          <a:prstGeom prst="rect">
-            <a:avLst/>
-          </a:prstGeom>
-          <a:noFill/>
-          <a:ln/>
-        </p:spPr>
-        <p:txBody>
-          <a:bodyPr wrap="square" lIns="25400" tIns="25400" rIns="25400" bIns="25400" rtlCol="0" anchor="ctr">
+            <a:off x="3680408" y="1599158"/>
+            <a:ext cx="648704" cy="128327"/>
+          </a:xfrm>
+          <a:prstGeom prst="rect">
+            <a:avLst/>
+          </a:prstGeom>
+          <a:noFill/>
+          <a:ln/>
+        </p:spPr>
+        <p:txBody>
+          <a:bodyPr wrap="square" lIns="12700" tIns="12700" rIns="12700" bIns="12700" rtlCol="0" anchor="ctr">
             <a:normAutofit/>
           </a:bodyPr>
           <a:lstStyle/>
@@ -1817,7 +1817,7 @@
               <a:buNone/>
             </a:pPr>
             <a:r>
-              <a:rPr lang="en-US" sz="1163" b="1" kern="0" spc="-12" dirty="0">
+              <a:rPr lang="en-US" sz="582" b="1" kern="0" spc="-6" dirty="0">
                 <a:solidFill>
                   <a:srgbClr val="0B1F3A"/>
                 </a:solidFill>
@@ -1827,7 +1827,7 @@
               </a:rPr>
               <a:t>75 000</a:t>
             </a:r>
-            <a:endParaRPr lang="en-US" sz="1163" dirty="0"/>
+            <a:endParaRPr lang="en-US" sz="582" dirty="0"/>
           </a:p>
         </p:txBody>
       </p:sp>
@@ -1839,8 +1839,8 @@
         </p:nvSpPr>
         <p:spPr>
           <a:xfrm>
-            <a:off x="1257300" y="3959275"/>
-            <a:ext cx="3289920" cy="9525"/>
+            <a:off x="628650" y="1979638"/>
+            <a:ext cx="1644960" cy="4762"/>
           </a:xfrm>
           <a:prstGeom prst="rect">
             <a:avLst/>
@@ -1859,17 +1859,17 @@
         </p:nvSpPr>
         <p:spPr>
           <a:xfrm>
-            <a:off x="1333500" y="3635946"/>
-            <a:ext cx="3236218" cy="256654"/>
-          </a:xfrm>
-          <a:prstGeom prst="rect">
-            <a:avLst/>
-          </a:prstGeom>
-          <a:noFill/>
-          <a:ln/>
-        </p:spPr>
-        <p:txBody>
-          <a:bodyPr wrap="square" lIns="25400" tIns="25400" rIns="25400" bIns="25400" rtlCol="0" anchor="ctr">
+            <a:off x="666750" y="1817973"/>
+            <a:ext cx="1618109" cy="128327"/>
+          </a:xfrm>
+          <a:prstGeom prst="rect">
+            <a:avLst/>
+          </a:prstGeom>
+          <a:noFill/>
+          <a:ln/>
+        </p:spPr>
+        <p:txBody>
+          <a:bodyPr wrap="square" lIns="12700" tIns="12700" rIns="12700" bIns="12700" rtlCol="0" anchor="ctr">
             <a:normAutofit/>
           </a:bodyPr>
           <a:lstStyle/>
@@ -1881,17 +1881,17 @@
               <a:buNone/>
             </a:pPr>
             <a:r>
-              <a:rPr lang="en-US" sz="1275" b="1" dirty="0">
+              <a:rPr lang="en-US" sz="638" b="1" dirty="0">
                 <a:solidFill>
                   <a:srgbClr val="0B1F3A"/>
                 </a:solidFill>
-                <a:latin typeface="-apple-system" pitchFamily="34" charset="0"/>
-                <a:ea typeface="-apple-system" pitchFamily="34" charset="-122"/>
-                <a:cs typeface="-apple-system" pitchFamily="34" charset="-120"/>
+                <a:latin typeface="Arial" pitchFamily="34" charset="0"/>
+                <a:ea typeface="Arial" pitchFamily="34" charset="-122"/>
+                <a:cs typeface="Arial" pitchFamily="34" charset="-120"/>
               </a:rPr>
               <a:t>Адаптер для КСО</a:t>
             </a:r>
-            <a:endParaRPr lang="en-US" sz="1275" dirty="0"/>
+            <a:endParaRPr lang="en-US" sz="638" dirty="0"/>
           </a:p>
         </p:txBody>
       </p:sp>
@@ -1903,8 +1903,8 @@
         </p:nvSpPr>
         <p:spPr>
           <a:xfrm>
-            <a:off x="4547220" y="3959275"/>
-            <a:ext cx="717724" cy="9525"/>
+            <a:off x="2273610" y="1979638"/>
+            <a:ext cx="358862" cy="4762"/>
           </a:xfrm>
           <a:prstGeom prst="rect">
             <a:avLst/>
@@ -1923,17 +1923,17 @@
         </p:nvSpPr>
         <p:spPr>
           <a:xfrm>
-            <a:off x="4547220" y="3635946"/>
-            <a:ext cx="641524" cy="256654"/>
-          </a:xfrm>
-          <a:prstGeom prst="rect">
-            <a:avLst/>
-          </a:prstGeom>
-          <a:noFill/>
-          <a:ln/>
-        </p:spPr>
-        <p:txBody>
-          <a:bodyPr wrap="square" lIns="25400" tIns="25400" rIns="25400" bIns="25400" rtlCol="0" anchor="ctr">
+            <a:off x="2273610" y="1817973"/>
+            <a:ext cx="320762" cy="128327"/>
+          </a:xfrm>
+          <a:prstGeom prst="rect">
+            <a:avLst/>
+          </a:prstGeom>
+          <a:noFill/>
+          <a:ln/>
+        </p:spPr>
+        <p:txBody>
+          <a:bodyPr wrap="square" lIns="12700" tIns="12700" rIns="12700" bIns="12700" rtlCol="0" anchor="ctr">
             <a:normAutofit/>
           </a:bodyPr>
           <a:lstStyle/>
@@ -1945,7 +1945,7 @@
               <a:buNone/>
             </a:pPr>
             <a:r>
-              <a:rPr lang="en-US" sz="1163" kern="0" spc="-12" dirty="0">
+              <a:rPr lang="en-US" sz="582" kern="0" spc="-6" dirty="0">
                 <a:solidFill>
                   <a:srgbClr val="29334A"/>
                 </a:solidFill>
@@ -1955,7 +1955,7 @@
               </a:rPr>
               <a:t>5</a:t>
             </a:r>
-            <a:endParaRPr lang="en-US" sz="1163" dirty="0"/>
+            <a:endParaRPr lang="en-US" sz="582" dirty="0"/>
           </a:p>
         </p:txBody>
       </p:sp>
@@ -1967,8 +1967,8 @@
         </p:nvSpPr>
         <p:spPr>
           <a:xfrm>
-            <a:off x="5264944" y="3959275"/>
-            <a:ext cx="1185863" cy="9525"/>
+            <a:off x="2632472" y="1979638"/>
+            <a:ext cx="592932" cy="4762"/>
           </a:xfrm>
           <a:prstGeom prst="rect">
             <a:avLst/>
@@ -1987,17 +1987,17 @@
         </p:nvSpPr>
         <p:spPr>
           <a:xfrm>
-            <a:off x="5264944" y="3635946"/>
-            <a:ext cx="1109662" cy="256654"/>
-          </a:xfrm>
-          <a:prstGeom prst="rect">
-            <a:avLst/>
-          </a:prstGeom>
-          <a:noFill/>
-          <a:ln/>
-        </p:spPr>
-        <p:txBody>
-          <a:bodyPr wrap="square" lIns="25400" tIns="25400" rIns="25400" bIns="25400" rtlCol="0" anchor="ctr">
+            <a:off x="2632472" y="1817973"/>
+            <a:ext cx="554831" cy="128327"/>
+          </a:xfrm>
+          <a:prstGeom prst="rect">
+            <a:avLst/>
+          </a:prstGeom>
+          <a:noFill/>
+          <a:ln/>
+        </p:spPr>
+        <p:txBody>
+          <a:bodyPr wrap="square" lIns="12700" tIns="12700" rIns="12700" bIns="12700" rtlCol="0" anchor="ctr">
             <a:normAutofit/>
           </a:bodyPr>
           <a:lstStyle/>
@@ -2009,7 +2009,7 @@
               <a:buNone/>
             </a:pPr>
             <a:r>
-              <a:rPr lang="en-US" sz="1163" kern="0" spc="-12" dirty="0">
+              <a:rPr lang="en-US" sz="582" kern="0" spc="-6" dirty="0">
                 <a:solidFill>
                   <a:srgbClr val="29334A"/>
                 </a:solidFill>
@@ -2019,7 +2019,7 @@
               </a:rPr>
               <a:t>10 000</a:t>
             </a:r>
-            <a:endParaRPr lang="en-US" sz="1163" dirty="0"/>
+            <a:endParaRPr lang="en-US" sz="582" dirty="0"/>
           </a:p>
         </p:txBody>
       </p:sp>
@@ -2031,8 +2031,8 @@
         </p:nvSpPr>
         <p:spPr>
           <a:xfrm>
-            <a:off x="6450806" y="3959275"/>
-            <a:ext cx="910010" cy="9525"/>
+            <a:off x="3225403" y="1979638"/>
+            <a:ext cx="455005" cy="4762"/>
           </a:xfrm>
           <a:prstGeom prst="rect">
             <a:avLst/>
@@ -2051,17 +2051,17 @@
         </p:nvSpPr>
         <p:spPr>
           <a:xfrm>
-            <a:off x="6450806" y="3635946"/>
-            <a:ext cx="833810" cy="256654"/>
-          </a:xfrm>
-          <a:prstGeom prst="rect">
-            <a:avLst/>
-          </a:prstGeom>
-          <a:noFill/>
-          <a:ln/>
-        </p:spPr>
-        <p:txBody>
-          <a:bodyPr wrap="square" lIns="25400" tIns="25400" rIns="25400" bIns="25400" rtlCol="0" anchor="ctr">
+            <a:off x="3225403" y="1817973"/>
+            <a:ext cx="416905" cy="128327"/>
+          </a:xfrm>
+          <a:prstGeom prst="rect">
+            <a:avLst/>
+          </a:prstGeom>
+          <a:noFill/>
+          <a:ln/>
+        </p:spPr>
+        <p:txBody>
+          <a:bodyPr wrap="square" lIns="12700" tIns="12700" rIns="12700" bIns="12700" rtlCol="0" anchor="ctr">
             <a:normAutofit/>
           </a:bodyPr>
           <a:lstStyle/>
@@ -2073,7 +2073,7 @@
               <a:buNone/>
             </a:pPr>
             <a:r>
-              <a:rPr lang="en-US" sz="1163" kern="0" spc="-12" dirty="0">
+              <a:rPr lang="en-US" sz="582" kern="0" spc="-6" dirty="0">
                 <a:solidFill>
                   <a:srgbClr val="B8BEC9"/>
                 </a:solidFill>
@@ -2083,7 +2083,7 @@
               </a:rPr>
               <a:t>—</a:t>
             </a:r>
-            <a:endParaRPr lang="en-US" sz="1163" dirty="0"/>
+            <a:endParaRPr lang="en-US" sz="582" dirty="0"/>
           </a:p>
         </p:txBody>
       </p:sp>
@@ -2095,8 +2095,8 @@
         </p:nvSpPr>
         <p:spPr>
           <a:xfrm>
-            <a:off x="7360816" y="3959275"/>
-            <a:ext cx="1373609" cy="9525"/>
+            <a:off x="3680408" y="1979638"/>
+            <a:ext cx="686804" cy="4762"/>
           </a:xfrm>
           <a:prstGeom prst="rect">
             <a:avLst/>
@@ -2115,17 +2115,17 @@
         </p:nvSpPr>
         <p:spPr>
           <a:xfrm>
-            <a:off x="7360816" y="3635946"/>
-            <a:ext cx="1297409" cy="256654"/>
-          </a:xfrm>
-          <a:prstGeom prst="rect">
-            <a:avLst/>
-          </a:prstGeom>
-          <a:noFill/>
-          <a:ln/>
-        </p:spPr>
-        <p:txBody>
-          <a:bodyPr wrap="square" lIns="25400" tIns="25400" rIns="25400" bIns="25400" rtlCol="0" anchor="ctr">
+            <a:off x="3680408" y="1817973"/>
+            <a:ext cx="648704" cy="128327"/>
+          </a:xfrm>
+          <a:prstGeom prst="rect">
+            <a:avLst/>
+          </a:prstGeom>
+          <a:noFill/>
+          <a:ln/>
+        </p:spPr>
+        <p:txBody>
+          <a:bodyPr wrap="square" lIns="12700" tIns="12700" rIns="12700" bIns="12700" rtlCol="0" anchor="ctr">
             <a:normAutofit/>
           </a:bodyPr>
           <a:lstStyle/>
@@ -2137,7 +2137,7 @@
               <a:buNone/>
             </a:pPr>
             <a:r>
-              <a:rPr lang="en-US" sz="1163" b="1" kern="0" spc="-12" dirty="0">
+              <a:rPr lang="en-US" sz="582" b="1" kern="0" spc="-6" dirty="0">
                 <a:solidFill>
                   <a:srgbClr val="0B1F3A"/>
                 </a:solidFill>
@@ -2147,7 +2147,7 @@
               </a:rPr>
               <a:t>50 000</a:t>
             </a:r>
-            <a:endParaRPr lang="en-US" sz="1163" dirty="0"/>
+            <a:endParaRPr lang="en-US" sz="582" dirty="0"/>
           </a:p>
         </p:txBody>
       </p:sp>
@@ -2159,8 +2159,8 @@
         </p:nvSpPr>
         <p:spPr>
           <a:xfrm>
-            <a:off x="1257300" y="4615458"/>
-            <a:ext cx="3289920" cy="9525"/>
+            <a:off x="628650" y="2307729"/>
+            <a:ext cx="1644960" cy="4762"/>
           </a:xfrm>
           <a:prstGeom prst="rect">
             <a:avLst/>
@@ -2179,17 +2179,17 @@
         </p:nvSpPr>
         <p:spPr>
           <a:xfrm>
-            <a:off x="1333500" y="4073575"/>
-            <a:ext cx="3236218" cy="475208"/>
-          </a:xfrm>
-          <a:prstGeom prst="rect">
-            <a:avLst/>
-          </a:prstGeom>
-          <a:noFill/>
-          <a:ln/>
-        </p:spPr>
-        <p:txBody>
-          <a:bodyPr wrap="square" lIns="25400" tIns="25400" rIns="25400" bIns="25400" rtlCol="0" anchor="ctr">
+            <a:off x="666750" y="2036788"/>
+            <a:ext cx="1618109" cy="237604"/>
+          </a:xfrm>
+          <a:prstGeom prst="rect">
+            <a:avLst/>
+          </a:prstGeom>
+          <a:noFill/>
+          <a:ln/>
+        </p:spPr>
+        <p:txBody>
+          <a:bodyPr wrap="square" lIns="12700" tIns="12700" rIns="12700" bIns="12700" rtlCol="0" anchor="ctr">
             <a:normAutofit/>
           </a:bodyPr>
           <a:lstStyle/>
@@ -2201,17 +2201,17 @@
               <a:buNone/>
             </a:pPr>
             <a:r>
-              <a:rPr lang="en-US" sz="1275" b="1" dirty="0">
+              <a:rPr lang="en-US" sz="638" b="1" dirty="0">
                 <a:solidFill>
                   <a:srgbClr val="0B1F3A"/>
                 </a:solidFill>
-                <a:latin typeface="-apple-system" pitchFamily="34" charset="0"/>
-                <a:ea typeface="-apple-system" pitchFamily="34" charset="-122"/>
-                <a:cs typeface="-apple-system" pitchFamily="34" charset="-120"/>
+                <a:latin typeface="Arial" pitchFamily="34" charset="0"/>
+                <a:ea typeface="Arial" pitchFamily="34" charset="-122"/>
+                <a:cs typeface="Arial" pitchFamily="34" charset="-120"/>
               </a:rPr>
               <a:t>Крепление для фискального регистратора</a:t>
             </a:r>
-            <a:endParaRPr lang="en-US" sz="1275" dirty="0"/>
+            <a:endParaRPr lang="en-US" sz="638" dirty="0"/>
           </a:p>
         </p:txBody>
       </p:sp>
@@ -2223,8 +2223,8 @@
         </p:nvSpPr>
         <p:spPr>
           <a:xfrm>
-            <a:off x="4547220" y="4615458"/>
-            <a:ext cx="717724" cy="9525"/>
+            <a:off x="2273610" y="2307729"/>
+            <a:ext cx="358862" cy="4762"/>
           </a:xfrm>
           <a:prstGeom prst="rect">
             <a:avLst/>
@@ -2243,17 +2243,17 @@
         </p:nvSpPr>
         <p:spPr>
           <a:xfrm>
-            <a:off x="4547220" y="4073575"/>
-            <a:ext cx="641524" cy="475208"/>
-          </a:xfrm>
-          <a:prstGeom prst="rect">
-            <a:avLst/>
-          </a:prstGeom>
-          <a:noFill/>
-          <a:ln/>
-        </p:spPr>
-        <p:txBody>
-          <a:bodyPr wrap="square" lIns="25400" tIns="25400" rIns="25400" bIns="25400" rtlCol="0" anchor="ctr">
+            <a:off x="2273610" y="2036788"/>
+            <a:ext cx="320762" cy="237604"/>
+          </a:xfrm>
+          <a:prstGeom prst="rect">
+            <a:avLst/>
+          </a:prstGeom>
+          <a:noFill/>
+          <a:ln/>
+        </p:spPr>
+        <p:txBody>
+          <a:bodyPr wrap="square" lIns="12700" tIns="12700" rIns="12700" bIns="12700" rtlCol="0" anchor="ctr">
             <a:normAutofit/>
           </a:bodyPr>
           <a:lstStyle/>
@@ -2265,7 +2265,7 @@
               <a:buNone/>
             </a:pPr>
             <a:r>
-              <a:rPr lang="en-US" sz="1163" kern="0" spc="-12" dirty="0">
+              <a:rPr lang="en-US" sz="582" kern="0" spc="-6" dirty="0">
                 <a:solidFill>
                   <a:srgbClr val="29334A"/>
                 </a:solidFill>
@@ -2275,7 +2275,7 @@
               </a:rPr>
               <a:t>5</a:t>
             </a:r>
-            <a:endParaRPr lang="en-US" sz="1163" dirty="0"/>
+            <a:endParaRPr lang="en-US" sz="582" dirty="0"/>
           </a:p>
         </p:txBody>
       </p:sp>
@@ -2287,8 +2287,8 @@
         </p:nvSpPr>
         <p:spPr>
           <a:xfrm>
-            <a:off x="5264944" y="4615458"/>
-            <a:ext cx="1185863" cy="9525"/>
+            <a:off x="2632472" y="2307729"/>
+            <a:ext cx="592932" cy="4762"/>
           </a:xfrm>
           <a:prstGeom prst="rect">
             <a:avLst/>
@@ -2307,17 +2307,17 @@
         </p:nvSpPr>
         <p:spPr>
           <a:xfrm>
-            <a:off x="5264944" y="4073575"/>
-            <a:ext cx="1109662" cy="475208"/>
-          </a:xfrm>
-          <a:prstGeom prst="rect">
-            <a:avLst/>
-          </a:prstGeom>
-          <a:noFill/>
-          <a:ln/>
-        </p:spPr>
-        <p:txBody>
-          <a:bodyPr wrap="square" lIns="25400" tIns="25400" rIns="25400" bIns="25400" rtlCol="0" anchor="ctr">
+            <a:off x="2632472" y="2036788"/>
+            <a:ext cx="554831" cy="237604"/>
+          </a:xfrm>
+          <a:prstGeom prst="rect">
+            <a:avLst/>
+          </a:prstGeom>
+          <a:noFill/>
+          <a:ln/>
+        </p:spPr>
+        <p:txBody>
+          <a:bodyPr wrap="square" lIns="12700" tIns="12700" rIns="12700" bIns="12700" rtlCol="0" anchor="ctr">
             <a:normAutofit/>
           </a:bodyPr>
           <a:lstStyle/>
@@ -2329,7 +2329,7 @@
               <a:buNone/>
             </a:pPr>
             <a:r>
-              <a:rPr lang="en-US" sz="1163" kern="0" spc="-12" dirty="0">
+              <a:rPr lang="en-US" sz="582" kern="0" spc="-6" dirty="0">
                 <a:solidFill>
                   <a:srgbClr val="29334A"/>
                 </a:solidFill>
@@ -2339,7 +2339,7 @@
               </a:rPr>
               <a:t>6 900</a:t>
             </a:r>
-            <a:endParaRPr lang="en-US" sz="1163" dirty="0"/>
+            <a:endParaRPr lang="en-US" sz="582" dirty="0"/>
           </a:p>
         </p:txBody>
       </p:sp>
@@ -2351,8 +2351,8 @@
         </p:nvSpPr>
         <p:spPr>
           <a:xfrm>
-            <a:off x="6450806" y="4615458"/>
-            <a:ext cx="910010" cy="9525"/>
+            <a:off x="3225403" y="2307729"/>
+            <a:ext cx="455005" cy="4762"/>
           </a:xfrm>
           <a:prstGeom prst="rect">
             <a:avLst/>
@@ -2371,17 +2371,17 @@
         </p:nvSpPr>
         <p:spPr>
           <a:xfrm>
-            <a:off x="6450806" y="4073575"/>
-            <a:ext cx="833810" cy="475208"/>
-          </a:xfrm>
-          <a:prstGeom prst="rect">
-            <a:avLst/>
-          </a:prstGeom>
-          <a:noFill/>
-          <a:ln/>
-        </p:spPr>
-        <p:txBody>
-          <a:bodyPr wrap="square" lIns="25400" tIns="25400" rIns="25400" bIns="25400" rtlCol="0" anchor="ctr">
+            <a:off x="3225403" y="2036788"/>
+            <a:ext cx="416905" cy="237604"/>
+          </a:xfrm>
+          <a:prstGeom prst="rect">
+            <a:avLst/>
+          </a:prstGeom>
+          <a:noFill/>
+          <a:ln/>
+        </p:spPr>
+        <p:txBody>
+          <a:bodyPr wrap="square" lIns="12700" tIns="12700" rIns="12700" bIns="12700" rtlCol="0" anchor="ctr">
             <a:normAutofit/>
           </a:bodyPr>
           <a:lstStyle/>
@@ -2393,7 +2393,7 @@
               <a:buNone/>
             </a:pPr>
             <a:r>
-              <a:rPr lang="en-US" sz="1163" kern="0" spc="-12" dirty="0">
+              <a:rPr lang="en-US" sz="582" kern="0" spc="-6" dirty="0">
                 <a:solidFill>
                   <a:srgbClr val="B8BEC9"/>
                 </a:solidFill>
@@ -2403,7 +2403,7 @@
               </a:rPr>
               <a:t>—</a:t>
             </a:r>
-            <a:endParaRPr lang="en-US" sz="1163" dirty="0"/>
+            <a:endParaRPr lang="en-US" sz="582" dirty="0"/>
           </a:p>
         </p:txBody>
       </p:sp>
@@ -2415,8 +2415,8 @@
         </p:nvSpPr>
         <p:spPr>
           <a:xfrm>
-            <a:off x="7360816" y="4615458"/>
-            <a:ext cx="1373609" cy="9525"/>
+            <a:off x="3680408" y="2307729"/>
+            <a:ext cx="686804" cy="4762"/>
           </a:xfrm>
           <a:prstGeom prst="rect">
             <a:avLst/>
@@ -2435,17 +2435,17 @@
         </p:nvSpPr>
         <p:spPr>
           <a:xfrm>
-            <a:off x="7360816" y="4073575"/>
-            <a:ext cx="1297409" cy="475208"/>
-          </a:xfrm>
-          <a:prstGeom prst="rect">
-            <a:avLst/>
-          </a:prstGeom>
-          <a:noFill/>
-          <a:ln/>
-        </p:spPr>
-        <p:txBody>
-          <a:bodyPr wrap="square" lIns="25400" tIns="25400" rIns="25400" bIns="25400" rtlCol="0" anchor="ctr">
+            <a:off x="3680408" y="2036788"/>
+            <a:ext cx="648704" cy="237604"/>
+          </a:xfrm>
+          <a:prstGeom prst="rect">
+            <a:avLst/>
+          </a:prstGeom>
+          <a:noFill/>
+          <a:ln/>
+        </p:spPr>
+        <p:txBody>
+          <a:bodyPr wrap="square" lIns="12700" tIns="12700" rIns="12700" bIns="12700" rtlCol="0" anchor="ctr">
             <a:normAutofit/>
           </a:bodyPr>
           <a:lstStyle/>
@@ -2457,7 +2457,7 @@
               <a:buNone/>
             </a:pPr>
             <a:r>
-              <a:rPr lang="en-US" sz="1163" b="1" kern="0" spc="-12" dirty="0">
+              <a:rPr lang="en-US" sz="582" b="1" kern="0" spc="-6" dirty="0">
                 <a:solidFill>
                   <a:srgbClr val="0B1F3A"/>
                 </a:solidFill>
@@ -2467,7 +2467,7 @@
               </a:rPr>
               <a:t>34 500</a:t>
             </a:r>
-            <a:endParaRPr lang="en-US" sz="1163" dirty="0"/>
+            <a:endParaRPr lang="en-US" sz="582" dirty="0"/>
           </a:p>
         </p:txBody>
       </p:sp>
@@ -2479,8 +2479,8 @@
         </p:nvSpPr>
         <p:spPr>
           <a:xfrm>
-            <a:off x="1257300" y="5053087"/>
-            <a:ext cx="3289920" cy="9525"/>
+            <a:off x="628650" y="2526544"/>
+            <a:ext cx="1644960" cy="4762"/>
           </a:xfrm>
           <a:prstGeom prst="rect">
             <a:avLst/>
@@ -2499,17 +2499,17 @@
         </p:nvSpPr>
         <p:spPr>
           <a:xfrm>
-            <a:off x="1333500" y="4729758"/>
-            <a:ext cx="3236218" cy="256654"/>
-          </a:xfrm>
-          <a:prstGeom prst="rect">
-            <a:avLst/>
-          </a:prstGeom>
-          <a:noFill/>
-          <a:ln/>
-        </p:spPr>
-        <p:txBody>
-          <a:bodyPr wrap="square" lIns="25400" tIns="25400" rIns="25400" bIns="25400" rtlCol="0" anchor="ctr">
+            <a:off x="666750" y="2364879"/>
+            <a:ext cx="1618109" cy="128327"/>
+          </a:xfrm>
+          <a:prstGeom prst="rect">
+            <a:avLst/>
+          </a:prstGeom>
+          <a:noFill/>
+          <a:ln/>
+        </p:spPr>
+        <p:txBody>
+          <a:bodyPr wrap="square" lIns="12700" tIns="12700" rIns="12700" bIns="12700" rtlCol="0" anchor="ctr">
             <a:normAutofit/>
           </a:bodyPr>
           <a:lstStyle/>
@@ -2521,17 +2521,17 @@
               <a:buNone/>
             </a:pPr>
             <a:r>
-              <a:rPr lang="en-US" sz="1275" b="1" dirty="0">
+              <a:rPr lang="en-US" sz="638" b="1" dirty="0">
                 <a:solidFill>
                   <a:srgbClr val="0B1F3A"/>
                 </a:solidFill>
-                <a:latin typeface="-apple-system" pitchFamily="34" charset="0"/>
-                <a:ea typeface="-apple-system" pitchFamily="34" charset="-122"/>
-                <a:cs typeface="-apple-system" pitchFamily="34" charset="-120"/>
+                <a:latin typeface="Arial" pitchFamily="34" charset="0"/>
+                <a:ea typeface="Arial" pitchFamily="34" charset="-122"/>
+                <a:cs typeface="Arial" pitchFamily="34" charset="-120"/>
               </a:rPr>
               <a:t>Фискальный регистратор без ФН</a:t>
             </a:r>
-            <a:endParaRPr lang="en-US" sz="1275" dirty="0"/>
+            <a:endParaRPr lang="en-US" sz="638" dirty="0"/>
           </a:p>
         </p:txBody>
       </p:sp>
@@ -2543,8 +2543,8 @@
         </p:nvSpPr>
         <p:spPr>
           <a:xfrm>
-            <a:off x="4547220" y="5053087"/>
-            <a:ext cx="717724" cy="9525"/>
+            <a:off x="2273610" y="2526544"/>
+            <a:ext cx="358862" cy="4762"/>
           </a:xfrm>
           <a:prstGeom prst="rect">
             <a:avLst/>
@@ -2563,17 +2563,17 @@
         </p:nvSpPr>
         <p:spPr>
           <a:xfrm>
-            <a:off x="4547220" y="4729758"/>
-            <a:ext cx="641524" cy="256654"/>
-          </a:xfrm>
-          <a:prstGeom prst="rect">
-            <a:avLst/>
-          </a:prstGeom>
-          <a:noFill/>
-          <a:ln/>
-        </p:spPr>
-        <p:txBody>
-          <a:bodyPr wrap="square" lIns="25400" tIns="25400" rIns="25400" bIns="25400" rtlCol="0" anchor="ctr">
+            <a:off x="2273610" y="2364879"/>
+            <a:ext cx="320762" cy="128327"/>
+          </a:xfrm>
+          <a:prstGeom prst="rect">
+            <a:avLst/>
+          </a:prstGeom>
+          <a:noFill/>
+          <a:ln/>
+        </p:spPr>
+        <p:txBody>
+          <a:bodyPr wrap="square" lIns="12700" tIns="12700" rIns="12700" bIns="12700" rtlCol="0" anchor="ctr">
             <a:normAutofit/>
           </a:bodyPr>
           <a:lstStyle/>
@@ -2585,7 +2585,7 @@
               <a:buNone/>
             </a:pPr>
             <a:r>
-              <a:rPr lang="en-US" sz="1163" kern="0" spc="-12" dirty="0">
+              <a:rPr lang="en-US" sz="582" kern="0" spc="-6" dirty="0">
                 <a:solidFill>
                   <a:srgbClr val="29334A"/>
                 </a:solidFill>
@@ -2595,7 +2595,7 @@
               </a:rPr>
               <a:t>5</a:t>
             </a:r>
-            <a:endParaRPr lang="en-US" sz="1163" dirty="0"/>
+            <a:endParaRPr lang="en-US" sz="582" dirty="0"/>
           </a:p>
         </p:txBody>
       </p:sp>
@@ -2607,8 +2607,8 @@
         </p:nvSpPr>
         <p:spPr>
           <a:xfrm>
-            <a:off x="5264944" y="5053087"/>
-            <a:ext cx="1185863" cy="9525"/>
+            <a:off x="2632472" y="2526544"/>
+            <a:ext cx="592932" cy="4762"/>
           </a:xfrm>
           <a:prstGeom prst="rect">
             <a:avLst/>
@@ -2627,17 +2627,17 @@
         </p:nvSpPr>
         <p:spPr>
           <a:xfrm>
-            <a:off x="5264944" y="4729758"/>
-            <a:ext cx="1109662" cy="256654"/>
-          </a:xfrm>
-          <a:prstGeom prst="rect">
-            <a:avLst/>
-          </a:prstGeom>
-          <a:noFill/>
-          <a:ln/>
-        </p:spPr>
-        <p:txBody>
-          <a:bodyPr wrap="square" lIns="25400" tIns="25400" rIns="25400" bIns="25400" rtlCol="0" anchor="ctr">
+            <a:off x="2632472" y="2364879"/>
+            <a:ext cx="554831" cy="128327"/>
+          </a:xfrm>
+          <a:prstGeom prst="rect">
+            <a:avLst/>
+          </a:prstGeom>
+          <a:noFill/>
+          <a:ln/>
+        </p:spPr>
+        <p:txBody>
+          <a:bodyPr wrap="square" lIns="12700" tIns="12700" rIns="12700" bIns="12700" rtlCol="0" anchor="ctr">
             <a:normAutofit/>
           </a:bodyPr>
           <a:lstStyle/>
@@ -2649,7 +2649,7 @@
               <a:buNone/>
             </a:pPr>
             <a:r>
-              <a:rPr lang="en-US" sz="1163" kern="0" spc="-12" dirty="0">
+              <a:rPr lang="en-US" sz="582" kern="0" spc="-6" dirty="0">
                 <a:solidFill>
                   <a:srgbClr val="29334A"/>
                 </a:solidFill>
@@ -2659,7 +2659,7 @@
               </a:rPr>
               <a:t>40 000</a:t>
             </a:r>
-            <a:endParaRPr lang="en-US" sz="1163" dirty="0"/>
+            <a:endParaRPr lang="en-US" sz="582" dirty="0"/>
           </a:p>
         </p:txBody>
       </p:sp>
@@ -2671,8 +2671,8 @@
         </p:nvSpPr>
         <p:spPr>
           <a:xfrm>
-            <a:off x="6450806" y="5053087"/>
-            <a:ext cx="910010" cy="9525"/>
+            <a:off x="3225403" y="2526544"/>
+            <a:ext cx="455005" cy="4762"/>
           </a:xfrm>
           <a:prstGeom prst="rect">
             <a:avLst/>
@@ -2691,17 +2691,17 @@
         </p:nvSpPr>
         <p:spPr>
           <a:xfrm>
-            <a:off x="6450806" y="4729758"/>
-            <a:ext cx="833810" cy="256654"/>
-          </a:xfrm>
-          <a:prstGeom prst="rect">
-            <a:avLst/>
-          </a:prstGeom>
-          <a:noFill/>
-          <a:ln/>
-        </p:spPr>
-        <p:txBody>
-          <a:bodyPr wrap="square" lIns="25400" tIns="25400" rIns="25400" bIns="25400" rtlCol="0" anchor="ctr">
+            <a:off x="3225403" y="2364879"/>
+            <a:ext cx="416905" cy="128327"/>
+          </a:xfrm>
+          <a:prstGeom prst="rect">
+            <a:avLst/>
+          </a:prstGeom>
+          <a:noFill/>
+          <a:ln/>
+        </p:spPr>
+        <p:txBody>
+          <a:bodyPr wrap="square" lIns="12700" tIns="12700" rIns="12700" bIns="12700" rtlCol="0" anchor="ctr">
             <a:normAutofit/>
           </a:bodyPr>
           <a:lstStyle/>
@@ -2713,7 +2713,7 @@
               <a:buNone/>
             </a:pPr>
             <a:r>
-              <a:rPr lang="en-US" sz="1163" b="1" kern="0" spc="-12" dirty="0">
+              <a:rPr lang="en-US" sz="582" b="1" kern="0" spc="-6" dirty="0">
                 <a:solidFill>
                   <a:srgbClr val="FF6A1A"/>
                 </a:solidFill>
@@ -2723,7 +2723,7 @@
               </a:rPr>
               <a:t>-10%</a:t>
             </a:r>
-            <a:endParaRPr lang="en-US" sz="1163" dirty="0"/>
+            <a:endParaRPr lang="en-US" sz="582" dirty="0"/>
           </a:p>
         </p:txBody>
       </p:sp>
@@ -2735,8 +2735,8 @@
         </p:nvSpPr>
         <p:spPr>
           <a:xfrm>
-            <a:off x="7360816" y="5053087"/>
-            <a:ext cx="1373609" cy="9525"/>
+            <a:off x="3680408" y="2526544"/>
+            <a:ext cx="686804" cy="4762"/>
           </a:xfrm>
           <a:prstGeom prst="rect">
             <a:avLst/>
@@ -2755,17 +2755,17 @@
         </p:nvSpPr>
         <p:spPr>
           <a:xfrm>
-            <a:off x="7360816" y="4729758"/>
-            <a:ext cx="1297409" cy="256654"/>
-          </a:xfrm>
-          <a:prstGeom prst="rect">
-            <a:avLst/>
-          </a:prstGeom>
-          <a:noFill/>
-          <a:ln/>
-        </p:spPr>
-        <p:txBody>
-          <a:bodyPr wrap="square" lIns="25400" tIns="25400" rIns="25400" bIns="25400" rtlCol="0" anchor="ctr">
+            <a:off x="3680408" y="2364879"/>
+            <a:ext cx="648704" cy="128327"/>
+          </a:xfrm>
+          <a:prstGeom prst="rect">
+            <a:avLst/>
+          </a:prstGeom>
+          <a:noFill/>
+          <a:ln/>
+        </p:spPr>
+        <p:txBody>
+          <a:bodyPr wrap="square" lIns="12700" tIns="12700" rIns="12700" bIns="12700" rtlCol="0" anchor="ctr">
             <a:normAutofit/>
           </a:bodyPr>
           <a:lstStyle/>
@@ -2777,7 +2777,7 @@
               <a:buNone/>
             </a:pPr>
             <a:r>
-              <a:rPr lang="en-US" sz="1163" b="1" kern="0" spc="-12" dirty="0">
+              <a:rPr lang="en-US" sz="582" b="1" kern="0" spc="-6" dirty="0">
                 <a:solidFill>
                   <a:srgbClr val="0B1F3A"/>
                 </a:solidFill>
@@ -2787,7 +2787,7 @@
               </a:rPr>
               <a:t>180 000</a:t>
             </a:r>
-            <a:endParaRPr lang="en-US" sz="1163" dirty="0"/>
+            <a:endParaRPr lang="en-US" sz="582" dirty="0"/>
           </a:p>
         </p:txBody>
       </p:sp>
@@ -2799,8 +2799,8 @@
         </p:nvSpPr>
         <p:spPr>
           <a:xfrm>
-            <a:off x="1257300" y="5490716"/>
-            <a:ext cx="3289920" cy="9525"/>
+            <a:off x="628650" y="2745358"/>
+            <a:ext cx="1644960" cy="4762"/>
           </a:xfrm>
           <a:prstGeom prst="rect">
             <a:avLst/>
@@ -2819,17 +2819,17 @@
         </p:nvSpPr>
         <p:spPr>
           <a:xfrm>
-            <a:off x="1333500" y="5167387"/>
-            <a:ext cx="3236218" cy="256654"/>
-          </a:xfrm>
-          <a:prstGeom prst="rect">
-            <a:avLst/>
-          </a:prstGeom>
-          <a:noFill/>
-          <a:ln/>
-        </p:spPr>
-        <p:txBody>
-          <a:bodyPr wrap="square" lIns="25400" tIns="25400" rIns="25400" bIns="25400" rtlCol="0" anchor="ctr">
+            <a:off x="666750" y="2583694"/>
+            <a:ext cx="1618109" cy="128327"/>
+          </a:xfrm>
+          <a:prstGeom prst="rect">
+            <a:avLst/>
+          </a:prstGeom>
+          <a:noFill/>
+          <a:ln/>
+        </p:spPr>
+        <p:txBody>
+          <a:bodyPr wrap="square" lIns="12700" tIns="12700" rIns="12700" bIns="12700" rtlCol="0" anchor="ctr">
             <a:normAutofit/>
           </a:bodyPr>
           <a:lstStyle/>
@@ -2841,17 +2841,17 @@
               <a:buNone/>
             </a:pPr>
             <a:r>
-              <a:rPr lang="en-US" sz="1275" b="1" dirty="0">
+              <a:rPr lang="en-US" sz="638" b="1" dirty="0">
                 <a:solidFill>
                   <a:srgbClr val="0B1F3A"/>
                 </a:solidFill>
-                <a:latin typeface="-apple-system" pitchFamily="34" charset="0"/>
-                <a:ea typeface="-apple-system" pitchFamily="34" charset="-122"/>
-                <a:cs typeface="-apple-system" pitchFamily="34" charset="-120"/>
+                <a:latin typeface="Arial" pitchFamily="34" charset="0"/>
+                <a:ea typeface="Arial" pitchFamily="34" charset="-122"/>
+                <a:cs typeface="Arial" pitchFamily="34" charset="-120"/>
               </a:rPr>
               <a:t>Мини-ПК, Intel Core i3, 8 ГБ ОЗУ</a:t>
             </a:r>
-            <a:endParaRPr lang="en-US" sz="1275" dirty="0"/>
+            <a:endParaRPr lang="en-US" sz="638" dirty="0"/>
           </a:p>
         </p:txBody>
       </p:sp>
@@ -2863,8 +2863,8 @@
         </p:nvSpPr>
         <p:spPr>
           <a:xfrm>
-            <a:off x="4547220" y="5490716"/>
-            <a:ext cx="717724" cy="9525"/>
+            <a:off x="2273610" y="2745358"/>
+            <a:ext cx="358862" cy="4762"/>
           </a:xfrm>
           <a:prstGeom prst="rect">
             <a:avLst/>
@@ -2883,17 +2883,17 @@
         </p:nvSpPr>
         <p:spPr>
           <a:xfrm>
-            <a:off x="4547220" y="5167387"/>
-            <a:ext cx="641524" cy="256654"/>
-          </a:xfrm>
-          <a:prstGeom prst="rect">
-            <a:avLst/>
-          </a:prstGeom>
-          <a:noFill/>
-          <a:ln/>
-        </p:spPr>
-        <p:txBody>
-          <a:bodyPr wrap="square" lIns="25400" tIns="25400" rIns="25400" bIns="25400" rtlCol="0" anchor="ctr">
+            <a:off x="2273610" y="2583694"/>
+            <a:ext cx="320762" cy="128327"/>
+          </a:xfrm>
+          <a:prstGeom prst="rect">
+            <a:avLst/>
+          </a:prstGeom>
+          <a:noFill/>
+          <a:ln/>
+        </p:spPr>
+        <p:txBody>
+          <a:bodyPr wrap="square" lIns="12700" tIns="12700" rIns="12700" bIns="12700" rtlCol="0" anchor="ctr">
             <a:normAutofit/>
           </a:bodyPr>
           <a:lstStyle/>
@@ -2905,7 +2905,7 @@
               <a:buNone/>
             </a:pPr>
             <a:r>
-              <a:rPr lang="en-US" sz="1163" kern="0" spc="-12" dirty="0">
+              <a:rPr lang="en-US" sz="582" kern="0" spc="-6" dirty="0">
                 <a:solidFill>
                   <a:srgbClr val="29334A"/>
                 </a:solidFill>
@@ -2915,7 +2915,7 @@
               </a:rPr>
               <a:t>1</a:t>
             </a:r>
-            <a:endParaRPr lang="en-US" sz="1163" dirty="0"/>
+            <a:endParaRPr lang="en-US" sz="582" dirty="0"/>
           </a:p>
         </p:txBody>
       </p:sp>
@@ -2927,8 +2927,8 @@
         </p:nvSpPr>
         <p:spPr>
           <a:xfrm>
-            <a:off x="5264944" y="5490716"/>
-            <a:ext cx="1185863" cy="9525"/>
+            <a:off x="2632472" y="2745358"/>
+            <a:ext cx="592932" cy="4762"/>
           </a:xfrm>
           <a:prstGeom prst="rect">
             <a:avLst/>
@@ -2947,17 +2947,17 @@
         </p:nvSpPr>
         <p:spPr>
           <a:xfrm>
-            <a:off x="5264944" y="5167387"/>
-            <a:ext cx="1109662" cy="256654"/>
-          </a:xfrm>
-          <a:prstGeom prst="rect">
-            <a:avLst/>
-          </a:prstGeom>
-          <a:noFill/>
-          <a:ln/>
-        </p:spPr>
-        <p:txBody>
-          <a:bodyPr wrap="square" lIns="25400" tIns="25400" rIns="25400" bIns="25400" rtlCol="0" anchor="ctr">
+            <a:off x="2632472" y="2583694"/>
+            <a:ext cx="554831" cy="128327"/>
+          </a:xfrm>
+          <a:prstGeom prst="rect">
+            <a:avLst/>
+          </a:prstGeom>
+          <a:noFill/>
+          <a:ln/>
+        </p:spPr>
+        <p:txBody>
+          <a:bodyPr wrap="square" lIns="12700" tIns="12700" rIns="12700" bIns="12700" rtlCol="0" anchor="ctr">
             <a:normAutofit/>
           </a:bodyPr>
           <a:lstStyle/>
@@ -2969,7 +2969,7 @@
               <a:buNone/>
             </a:pPr>
             <a:r>
-              <a:rPr lang="en-US" sz="1163" kern="0" spc="-12" dirty="0">
+              <a:rPr lang="en-US" sz="582" kern="0" spc="-6" dirty="0">
                 <a:solidFill>
                   <a:srgbClr val="29334A"/>
                 </a:solidFill>
@@ -2979,7 +2979,7 @@
               </a:rPr>
               <a:t>27 000</a:t>
             </a:r>
-            <a:endParaRPr lang="en-US" sz="1163" dirty="0"/>
+            <a:endParaRPr lang="en-US" sz="582" dirty="0"/>
           </a:p>
         </p:txBody>
       </p:sp>
@@ -2991,8 +2991,8 @@
         </p:nvSpPr>
         <p:spPr>
           <a:xfrm>
-            <a:off x="6450806" y="5490716"/>
-            <a:ext cx="910010" cy="9525"/>
+            <a:off x="3225403" y="2745358"/>
+            <a:ext cx="455005" cy="4762"/>
           </a:xfrm>
           <a:prstGeom prst="rect">
             <a:avLst/>
@@ -3011,17 +3011,17 @@
         </p:nvSpPr>
         <p:spPr>
           <a:xfrm>
-            <a:off x="6450806" y="5167387"/>
-            <a:ext cx="833810" cy="256654"/>
-          </a:xfrm>
-          <a:prstGeom prst="rect">
-            <a:avLst/>
-          </a:prstGeom>
-          <a:noFill/>
-          <a:ln/>
-        </p:spPr>
-        <p:txBody>
-          <a:bodyPr wrap="square" lIns="25400" tIns="25400" rIns="25400" bIns="25400" rtlCol="0" anchor="ctr">
+            <a:off x="3225403" y="2583694"/>
+            <a:ext cx="416905" cy="128327"/>
+          </a:xfrm>
+          <a:prstGeom prst="rect">
+            <a:avLst/>
+          </a:prstGeom>
+          <a:noFill/>
+          <a:ln/>
+        </p:spPr>
+        <p:txBody>
+          <a:bodyPr wrap="square" lIns="12700" tIns="12700" rIns="12700" bIns="12700" rtlCol="0" anchor="ctr">
             <a:normAutofit/>
           </a:bodyPr>
           <a:lstStyle/>
@@ -3033,7 +3033,7 @@
               <a:buNone/>
             </a:pPr>
             <a:r>
-              <a:rPr lang="en-US" sz="1163" b="1" kern="0" spc="-12" dirty="0">
+              <a:rPr lang="en-US" sz="582" b="1" kern="0" spc="-6" dirty="0">
                 <a:solidFill>
                   <a:srgbClr val="FF6A1A"/>
                 </a:solidFill>
@@ -3043,7 +3043,7 @@
               </a:rPr>
               <a:t>-20%</a:t>
             </a:r>
-            <a:endParaRPr lang="en-US" sz="1163" dirty="0"/>
+            <a:endParaRPr lang="en-US" sz="582" dirty="0"/>
           </a:p>
         </p:txBody>
       </p:sp>
@@ -3055,8 +3055,8 @@
         </p:nvSpPr>
         <p:spPr>
           <a:xfrm>
-            <a:off x="7360816" y="5490716"/>
-            <a:ext cx="1373609" cy="9525"/>
+            <a:off x="3680408" y="2745358"/>
+            <a:ext cx="686804" cy="4762"/>
           </a:xfrm>
           <a:prstGeom prst="rect">
             <a:avLst/>
@@ -3075,17 +3075,17 @@
         </p:nvSpPr>
         <p:spPr>
           <a:xfrm>
-            <a:off x="7360816" y="5167387"/>
-            <a:ext cx="1297409" cy="256654"/>
-          </a:xfrm>
-          <a:prstGeom prst="rect">
-            <a:avLst/>
-          </a:prstGeom>
-          <a:noFill/>
-          <a:ln/>
-        </p:spPr>
-        <p:txBody>
-          <a:bodyPr wrap="square" lIns="25400" tIns="25400" rIns="25400" bIns="25400" rtlCol="0" anchor="ctr">
+            <a:off x="3680408" y="2583694"/>
+            <a:ext cx="648704" cy="128327"/>
+          </a:xfrm>
+          <a:prstGeom prst="rect">
+            <a:avLst/>
+          </a:prstGeom>
+          <a:noFill/>
+          <a:ln/>
+        </p:spPr>
+        <p:txBody>
+          <a:bodyPr wrap="square" lIns="12700" tIns="12700" rIns="12700" bIns="12700" rtlCol="0" anchor="ctr">
             <a:normAutofit/>
           </a:bodyPr>
           <a:lstStyle/>
@@ -3097,7 +3097,7 @@
               <a:buNone/>
             </a:pPr>
             <a:r>
-              <a:rPr lang="en-US" sz="1163" b="1" kern="0" spc="-12" dirty="0">
+              <a:rPr lang="en-US" sz="582" b="1" kern="0" spc="-6" dirty="0">
                 <a:solidFill>
                   <a:srgbClr val="0B1F3A"/>
                 </a:solidFill>
@@ -3107,7 +3107,7 @@
               </a:rPr>
               <a:t>21 600</a:t>
             </a:r>
-            <a:endParaRPr lang="en-US" sz="1163" dirty="0"/>
+            <a:endParaRPr lang="en-US" sz="582" dirty="0"/>
           </a:p>
         </p:txBody>
       </p:sp>
@@ -3119,17 +3119,17 @@
         </p:nvSpPr>
         <p:spPr>
           <a:xfrm>
-            <a:off x="1333500" y="5605016"/>
-            <a:ext cx="3236218" cy="479971"/>
-          </a:xfrm>
-          <a:prstGeom prst="rect">
-            <a:avLst/>
-          </a:prstGeom>
-          <a:noFill/>
-          <a:ln/>
-        </p:spPr>
-        <p:txBody>
-          <a:bodyPr wrap="square" lIns="25400" tIns="25400" rIns="25400" bIns="25400" rtlCol="0" anchor="ctr">
+            <a:off x="666750" y="2802508"/>
+            <a:ext cx="1618109" cy="239986"/>
+          </a:xfrm>
+          <a:prstGeom prst="rect">
+            <a:avLst/>
+          </a:prstGeom>
+          <a:noFill/>
+          <a:ln/>
+        </p:spPr>
+        <p:txBody>
+          <a:bodyPr wrap="square" lIns="12700" tIns="12700" rIns="12700" bIns="12700" rtlCol="0" anchor="ctr">
             <a:normAutofit/>
           </a:bodyPr>
           <a:lstStyle/>
@@ -3141,17 +3141,17 @@
               <a:buNone/>
             </a:pPr>
             <a:r>
-              <a:rPr lang="en-US" sz="1275" b="1" dirty="0">
+              <a:rPr lang="en-US" sz="638" b="1" dirty="0">
                 <a:solidFill>
                   <a:srgbClr val="0B1F3A"/>
                 </a:solidFill>
-                <a:latin typeface="-apple-system" pitchFamily="34" charset="0"/>
-                <a:ea typeface="-apple-system" pitchFamily="34" charset="-122"/>
-                <a:cs typeface="-apple-system" pitchFamily="34" charset="-120"/>
+                <a:latin typeface="Arial" pitchFamily="34" charset="0"/>
+                <a:ea typeface="Arial" pitchFamily="34" charset="-122"/>
+                <a:cs typeface="Arial" pitchFamily="34" charset="-120"/>
               </a:rPr>
               <a:t>Smart TV 4K, 55″ + настенный кронштейн</a:t>
             </a:r>
-            <a:endParaRPr lang="en-US" sz="1275" dirty="0"/>
+            <a:endParaRPr lang="en-US" sz="638" dirty="0"/>
           </a:p>
         </p:txBody>
       </p:sp>
@@ -3163,17 +3163,17 @@
         </p:nvSpPr>
         <p:spPr>
           <a:xfrm>
-            <a:off x="4547220" y="5605016"/>
-            <a:ext cx="641524" cy="479971"/>
-          </a:xfrm>
-          <a:prstGeom prst="rect">
-            <a:avLst/>
-          </a:prstGeom>
-          <a:noFill/>
-          <a:ln/>
-        </p:spPr>
-        <p:txBody>
-          <a:bodyPr wrap="square" lIns="25400" tIns="25400" rIns="25400" bIns="25400" rtlCol="0" anchor="ctr">
+            <a:off x="2273610" y="2802508"/>
+            <a:ext cx="320762" cy="239986"/>
+          </a:xfrm>
+          <a:prstGeom prst="rect">
+            <a:avLst/>
+          </a:prstGeom>
+          <a:noFill/>
+          <a:ln/>
+        </p:spPr>
+        <p:txBody>
+          <a:bodyPr wrap="square" lIns="12700" tIns="12700" rIns="12700" bIns="12700" rtlCol="0" anchor="ctr">
             <a:normAutofit/>
           </a:bodyPr>
           <a:lstStyle/>
@@ -3185,7 +3185,7 @@
               <a:buNone/>
             </a:pPr>
             <a:r>
-              <a:rPr lang="en-US" sz="1163" kern="0" spc="-12" dirty="0">
+              <a:rPr lang="en-US" sz="582" kern="0" spc="-6" dirty="0">
                 <a:solidFill>
                   <a:srgbClr val="29334A"/>
                 </a:solidFill>
@@ -3195,7 +3195,7 @@
               </a:rPr>
               <a:t>1</a:t>
             </a:r>
-            <a:endParaRPr lang="en-US" sz="1163" dirty="0"/>
+            <a:endParaRPr lang="en-US" sz="582" dirty="0"/>
           </a:p>
         </p:txBody>
       </p:sp>
@@ -3207,17 +3207,17 @@
         </p:nvSpPr>
         <p:spPr>
           <a:xfrm>
-            <a:off x="5264944" y="5605016"/>
-            <a:ext cx="1109662" cy="479971"/>
-          </a:xfrm>
-          <a:prstGeom prst="rect">
-            <a:avLst/>
-          </a:prstGeom>
-          <a:noFill/>
-          <a:ln/>
-        </p:spPr>
-        <p:txBody>
-          <a:bodyPr wrap="square" lIns="25400" tIns="25400" rIns="25400" bIns="25400" rtlCol="0" anchor="ctr">
+            <a:off x="2632472" y="2802508"/>
+            <a:ext cx="554831" cy="239986"/>
+          </a:xfrm>
+          <a:prstGeom prst="rect">
+            <a:avLst/>
+          </a:prstGeom>
+          <a:noFill/>
+          <a:ln/>
+        </p:spPr>
+        <p:txBody>
+          <a:bodyPr wrap="square" lIns="12700" tIns="12700" rIns="12700" bIns="12700" rtlCol="0" anchor="ctr">
             <a:normAutofit/>
           </a:bodyPr>
           <a:lstStyle/>
@@ -3229,7 +3229,7 @@
               <a:buNone/>
             </a:pPr>
             <a:r>
-              <a:rPr lang="en-US" sz="1163" kern="0" spc="-12" dirty="0">
+              <a:rPr lang="en-US" sz="582" kern="0" spc="-6" dirty="0">
                 <a:solidFill>
                   <a:srgbClr val="29334A"/>
                 </a:solidFill>
@@ -3239,7 +3239,7 @@
               </a:rPr>
               <a:t>62 000</a:t>
             </a:r>
-            <a:endParaRPr lang="en-US" sz="1163" dirty="0"/>
+            <a:endParaRPr lang="en-US" sz="582" dirty="0"/>
           </a:p>
         </p:txBody>
       </p:sp>
@@ -3251,17 +3251,17 @@
         </p:nvSpPr>
         <p:spPr>
           <a:xfrm>
-            <a:off x="6450806" y="5605016"/>
-            <a:ext cx="833810" cy="479971"/>
-          </a:xfrm>
-          <a:prstGeom prst="rect">
-            <a:avLst/>
-          </a:prstGeom>
-          <a:noFill/>
-          <a:ln/>
-        </p:spPr>
-        <p:txBody>
-          <a:bodyPr wrap="square" lIns="25400" tIns="25400" rIns="25400" bIns="25400" rtlCol="0" anchor="ctr">
+            <a:off x="3225403" y="2802508"/>
+            <a:ext cx="416905" cy="239986"/>
+          </a:xfrm>
+          <a:prstGeom prst="rect">
+            <a:avLst/>
+          </a:prstGeom>
+          <a:noFill/>
+          <a:ln/>
+        </p:spPr>
+        <p:txBody>
+          <a:bodyPr wrap="square" lIns="12700" tIns="12700" rIns="12700" bIns="12700" rtlCol="0" anchor="ctr">
             <a:normAutofit/>
           </a:bodyPr>
           <a:lstStyle/>
@@ -3273,7 +3273,7 @@
               <a:buNone/>
             </a:pPr>
             <a:r>
-              <a:rPr lang="en-US" sz="1163" b="1" kern="0" spc="-12" dirty="0">
+              <a:rPr lang="en-US" sz="582" b="1" kern="0" spc="-6" dirty="0">
                 <a:solidFill>
                   <a:srgbClr val="FF6A1A"/>
                 </a:solidFill>
@@ -3283,7 +3283,7 @@
               </a:rPr>
               <a:t>-10%</a:t>
             </a:r>
-            <a:endParaRPr lang="en-US" sz="1163" dirty="0"/>
+            <a:endParaRPr lang="en-US" sz="582" dirty="0"/>
           </a:p>
         </p:txBody>
       </p:sp>
@@ -3295,17 +3295,17 @@
         </p:nvSpPr>
         <p:spPr>
           <a:xfrm>
-            <a:off x="7360816" y="5605016"/>
-            <a:ext cx="1297409" cy="479971"/>
-          </a:xfrm>
-          <a:prstGeom prst="rect">
-            <a:avLst/>
-          </a:prstGeom>
-          <a:noFill/>
-          <a:ln/>
-        </p:spPr>
-        <p:txBody>
-          <a:bodyPr wrap="square" lIns="25400" tIns="25400" rIns="25400" bIns="25400" rtlCol="0" anchor="ctr">
+            <a:off x="3680408" y="2802508"/>
+            <a:ext cx="648704" cy="239986"/>
+          </a:xfrm>
+          <a:prstGeom prst="rect">
+            <a:avLst/>
+          </a:prstGeom>
+          <a:noFill/>
+          <a:ln/>
+        </p:spPr>
+        <p:txBody>
+          <a:bodyPr wrap="square" lIns="12700" tIns="12700" rIns="12700" bIns="12700" rtlCol="0" anchor="ctr">
             <a:normAutofit/>
           </a:bodyPr>
           <a:lstStyle/>
@@ -3317,7 +3317,7 @@
               <a:buNone/>
             </a:pPr>
             <a:r>
-              <a:rPr lang="en-US" sz="1163" b="1" kern="0" spc="-12" dirty="0">
+              <a:rPr lang="en-US" sz="582" b="1" kern="0" spc="-6" dirty="0">
                 <a:solidFill>
                   <a:srgbClr val="0B1F3A"/>
                 </a:solidFill>
@@ -3327,7 +3327,7 @@
               </a:rPr>
               <a:t>55 800</a:t>
             </a:r>
-            <a:endParaRPr lang="en-US" sz="1163" dirty="0"/>
+            <a:endParaRPr lang="en-US" sz="582" dirty="0"/>
           </a:p>
         </p:txBody>
       </p:sp>
@@ -3339,8 +3339,8 @@
         </p:nvSpPr>
         <p:spPr>
           <a:xfrm>
-            <a:off x="1257300" y="6285012"/>
-            <a:ext cx="7477125" cy="19050"/>
+            <a:off x="628650" y="3142506"/>
+            <a:ext cx="3738562" cy="9525"/>
           </a:xfrm>
           <a:prstGeom prst="rect">
             <a:avLst/>
@@ -3359,18 +3359,18 @@
         </p:nvSpPr>
         <p:spPr>
           <a:xfrm>
-            <a:off x="1257300" y="6504087"/>
-            <a:ext cx="625227" cy="219075"/>
-          </a:xfrm>
-          <a:prstGeom prst="rect">
-            <a:avLst/>
-          </a:prstGeom>
-          <a:noFill/>
-          <a:ln/>
-        </p:spPr>
-        <p:txBody>
-          <a:bodyPr wrap="square" lIns="25400" tIns="25400" rIns="25400" bIns="25400" rtlCol="0" anchor="t">
-            <a:normAutofit/>
+            <a:off x="628650" y="3252044"/>
+            <a:ext cx="500000" cy="109538"/>
+          </a:xfrm>
+          <a:prstGeom prst="rect">
+            <a:avLst/>
+          </a:prstGeom>
+          <a:noFill/>
+          <a:ln/>
+        </p:spPr>
+        <p:txBody>
+          <a:bodyPr wrap="none" lIns="12700" tIns="12700" rIns="12700" bIns="12700" rtlCol="0" anchor="t">
+            <a:noAutofit/>
           </a:bodyPr>
           <a:lstStyle/>
           <a:p>
@@ -3378,17 +3378,17 @@
               <a:buNone/>
             </a:pPr>
             <a:r>
-              <a:rPr lang="en-US" sz="1200" b="1" kern="0" spc="24" dirty="0">
+              <a:rPr lang="en-US" sz="600" b="1" kern="0" spc="12" dirty="0">
                 <a:solidFill>
                   <a:srgbClr val="0B1F3A"/>
                 </a:solidFill>
-                <a:latin typeface="-apple-system" pitchFamily="34" charset="0"/>
-                <a:ea typeface="-apple-system" pitchFamily="34" charset="-122"/>
-                <a:cs typeface="-apple-system" pitchFamily="34" charset="-120"/>
+                <a:latin typeface="Arial" pitchFamily="34" charset="0"/>
+                <a:ea typeface="Arial" pitchFamily="34" charset="-122"/>
+                <a:cs typeface="Arial" pitchFamily="34" charset="-120"/>
               </a:rPr>
               <a:t>ИТОГО</a:t>
             </a:r>
-            <a:endParaRPr lang="en-US" sz="1200" dirty="0"/>
+            <a:endParaRPr lang="en-US" sz="600" dirty="0"/>
           </a:p>
         </p:txBody>
       </p:sp>
@@ -3400,17 +3400,17 @@
         </p:nvSpPr>
         <p:spPr>
           <a:xfrm>
-            <a:off x="7602810" y="6437412"/>
-            <a:ext cx="1207815" cy="314325"/>
-          </a:xfrm>
-          <a:prstGeom prst="rect">
-            <a:avLst/>
-          </a:prstGeom>
-          <a:noFill/>
-          <a:ln/>
-        </p:spPr>
-        <p:txBody>
-          <a:bodyPr wrap="square" lIns="25400" tIns="25400" rIns="25400" bIns="25400" rtlCol="0" anchor="t">
+            <a:off x="3801405" y="3218706"/>
+            <a:ext cx="603908" cy="157162"/>
+          </a:xfrm>
+          <a:prstGeom prst="rect">
+            <a:avLst/>
+          </a:prstGeom>
+          <a:noFill/>
+          <a:ln/>
+        </p:spPr>
+        <p:txBody>
+          <a:bodyPr wrap="square" lIns="12700" tIns="12700" rIns="12700" bIns="12700" rtlCol="0" anchor="t">
             <a:normAutofit/>
           </a:bodyPr>
           <a:lstStyle/>
@@ -3419,7 +3419,7 @@
               <a:buNone/>
             </a:pPr>
             <a:r>
-              <a:rPr lang="en-US" sz="1650" b="1" dirty="0">
+              <a:rPr lang="en-US" sz="825" b="1" dirty="0">
                 <a:solidFill>
                   <a:srgbClr val="0B1F3A"/>
                 </a:solidFill>
@@ -3429,7 +3429,7 @@
               </a:rPr>
               <a:t>867 400 ₽</a:t>
             </a:r>
-            <a:endParaRPr lang="en-US" sz="1650" dirty="0"/>
+            <a:endParaRPr lang="en-US" sz="825" dirty="0"/>
           </a:p>
         </p:txBody>
       </p:sp>
@@ -3441,8 +3441,8 @@
         </p:nvSpPr>
         <p:spPr>
           <a:xfrm>
-            <a:off x="9248775" y="1683916"/>
-            <a:ext cx="8086725" cy="2954015"/>
+            <a:off x="4624388" y="841958"/>
+            <a:ext cx="4043362" cy="1477008"/>
           </a:xfrm>
           <a:prstGeom prst="roundRect">
             <a:avLst>
@@ -3470,17 +3470,17 @@
         </p:nvSpPr>
         <p:spPr>
           <a:xfrm>
-            <a:off x="9553575" y="1931566"/>
-            <a:ext cx="7701439" cy="304800"/>
-          </a:xfrm>
-          <a:prstGeom prst="rect">
-            <a:avLst/>
-          </a:prstGeom>
-          <a:noFill/>
-          <a:ln/>
-        </p:spPr>
-        <p:txBody>
-          <a:bodyPr wrap="square" lIns="25400" tIns="25400" rIns="25400" bIns="25400" rtlCol="0" anchor="ctr">
+            <a:off x="4776788" y="965783"/>
+            <a:ext cx="3850720" cy="152400"/>
+          </a:xfrm>
+          <a:prstGeom prst="rect">
+            <a:avLst/>
+          </a:prstGeom>
+          <a:noFill/>
+          <a:ln/>
+        </p:spPr>
+        <p:txBody>
+          <a:bodyPr wrap="square" lIns="12700" tIns="12700" rIns="12700" bIns="12700" rtlCol="0" anchor="ctr">
             <a:normAutofit/>
           </a:bodyPr>
           <a:lstStyle/>
@@ -3489,17 +3489,17 @@
               <a:buNone/>
             </a:pPr>
             <a:r>
-              <a:rPr lang="en-US" sz="1800" b="1" kern="0" spc="-9" dirty="0">
+              <a:rPr lang="en-US" sz="900" b="1" kern="0" spc="-4" dirty="0">
                 <a:solidFill>
                   <a:srgbClr val="0B1F3A"/>
                 </a:solidFill>
-                <a:latin typeface="-apple-system" pitchFamily="34" charset="0"/>
-                <a:ea typeface="-apple-system" pitchFamily="34" charset="-122"/>
-                <a:cs typeface="-apple-system" pitchFamily="34" charset="-120"/>
+                <a:latin typeface="Arial" pitchFamily="34" charset="0"/>
+                <a:ea typeface="Arial" pitchFamily="34" charset="-122"/>
+                <a:cs typeface="Arial" pitchFamily="34" charset="-120"/>
               </a:rPr>
               <a:t>Лицензии и подписки</a:t>
             </a:r>
-            <a:endParaRPr lang="en-US" sz="1800" dirty="0"/>
+            <a:endParaRPr lang="en-US" sz="900" dirty="0"/>
           </a:p>
         </p:txBody>
       </p:sp>
@@ -3511,8 +3511,8 @@
         </p:nvSpPr>
         <p:spPr>
           <a:xfrm>
-            <a:off x="9553575" y="2646387"/>
-            <a:ext cx="3289920" cy="9525"/>
+            <a:off x="4776788" y="1323194"/>
+            <a:ext cx="1644960" cy="4762"/>
           </a:xfrm>
           <a:prstGeom prst="rect">
             <a:avLst/>
@@ -3531,17 +3531,17 @@
         </p:nvSpPr>
         <p:spPr>
           <a:xfrm>
-            <a:off x="9629775" y="2388766"/>
-            <a:ext cx="3236218" cy="200471"/>
-          </a:xfrm>
-          <a:prstGeom prst="rect">
-            <a:avLst/>
-          </a:prstGeom>
-          <a:noFill/>
-          <a:ln/>
-        </p:spPr>
-        <p:txBody>
-          <a:bodyPr wrap="square" lIns="25400" tIns="25400" rIns="25400" bIns="25400" rtlCol="0" anchor="ctr">
+            <a:off x="4814888" y="1194383"/>
+            <a:ext cx="1618109" cy="100236"/>
+          </a:xfrm>
+          <a:prstGeom prst="rect">
+            <a:avLst/>
+          </a:prstGeom>
+          <a:noFill/>
+          <a:ln/>
+        </p:spPr>
+        <p:txBody>
+          <a:bodyPr wrap="square" lIns="12700" tIns="12700" rIns="12700" bIns="12700" rtlCol="0" anchor="ctr">
             <a:normAutofit/>
           </a:bodyPr>
           <a:lstStyle/>
@@ -3553,17 +3553,17 @@
               <a:buNone/>
             </a:pPr>
             <a:r>
-              <a:rPr lang="en-US" sz="975" b="1" kern="0" spc="78" dirty="0">
+              <a:rPr lang="en-US" sz="488" b="1" kern="0" spc="39" dirty="0">
                 <a:solidFill>
                   <a:srgbClr val="6A7285"/>
                 </a:solidFill>
-                <a:latin typeface="-apple-system" pitchFamily="34" charset="0"/>
-                <a:ea typeface="-apple-system" pitchFamily="34" charset="-122"/>
-                <a:cs typeface="-apple-system" pitchFamily="34" charset="-120"/>
+                <a:latin typeface="Arial" pitchFamily="34" charset="0"/>
+                <a:ea typeface="Arial" pitchFamily="34" charset="-122"/>
+                <a:cs typeface="Arial" pitchFamily="34" charset="-120"/>
               </a:rPr>
               <a:t>НАИМЕНОВАНИЕ</a:t>
             </a:r>
-            <a:endParaRPr lang="en-US" sz="975" dirty="0"/>
+            <a:endParaRPr lang="en-US" sz="488" dirty="0"/>
           </a:p>
         </p:txBody>
       </p:sp>
@@ -3575,8 +3575,8 @@
         </p:nvSpPr>
         <p:spPr>
           <a:xfrm>
-            <a:off x="12843495" y="2646387"/>
-            <a:ext cx="718245" cy="9525"/>
+            <a:off x="6421748" y="1323194"/>
+            <a:ext cx="359122" cy="4762"/>
           </a:xfrm>
           <a:prstGeom prst="rect">
             <a:avLst/>
@@ -3595,17 +3595,17 @@
         </p:nvSpPr>
         <p:spPr>
           <a:xfrm>
-            <a:off x="12843495" y="2388766"/>
-            <a:ext cx="642045" cy="200471"/>
-          </a:xfrm>
-          <a:prstGeom prst="rect">
-            <a:avLst/>
-          </a:prstGeom>
-          <a:noFill/>
-          <a:ln/>
-        </p:spPr>
-        <p:txBody>
-          <a:bodyPr wrap="square" lIns="25400" tIns="25400" rIns="25400" bIns="25400" rtlCol="0" anchor="ctr">
+            <a:off x="6421748" y="1194383"/>
+            <a:ext cx="321022" cy="100236"/>
+          </a:xfrm>
+          <a:prstGeom prst="rect">
+            <a:avLst/>
+          </a:prstGeom>
+          <a:noFill/>
+          <a:ln/>
+        </p:spPr>
+        <p:txBody>
+          <a:bodyPr wrap="square" lIns="12700" tIns="12700" rIns="12700" bIns="12700" rtlCol="0" anchor="ctr">
             <a:normAutofit/>
           </a:bodyPr>
           <a:lstStyle/>
@@ -3617,17 +3617,17 @@
               <a:buNone/>
             </a:pPr>
             <a:r>
-              <a:rPr lang="en-US" sz="975" b="1" kern="0" spc="78" dirty="0">
+              <a:rPr lang="en-US" sz="488" b="1" kern="0" spc="39" dirty="0">
                 <a:solidFill>
                   <a:srgbClr val="6A7285"/>
                 </a:solidFill>
-                <a:latin typeface="-apple-system" pitchFamily="34" charset="0"/>
-                <a:ea typeface="-apple-system" pitchFamily="34" charset="-122"/>
-                <a:cs typeface="-apple-system" pitchFamily="34" charset="-120"/>
+                <a:latin typeface="Arial" pitchFamily="34" charset="0"/>
+                <a:ea typeface="Arial" pitchFamily="34" charset="-122"/>
+                <a:cs typeface="Arial" pitchFamily="34" charset="-120"/>
               </a:rPr>
               <a:t>КОЛ.</a:t>
             </a:r>
-            <a:endParaRPr lang="en-US" sz="975" dirty="0"/>
+            <a:endParaRPr lang="en-US" sz="488" dirty="0"/>
           </a:p>
         </p:txBody>
       </p:sp>
@@ -3639,8 +3639,8 @@
         </p:nvSpPr>
         <p:spPr>
           <a:xfrm>
-            <a:off x="13561740" y="2646387"/>
-            <a:ext cx="1185193" cy="9525"/>
+            <a:off x="6780870" y="1323194"/>
+            <a:ext cx="592596" cy="4762"/>
           </a:xfrm>
           <a:prstGeom prst="rect">
             <a:avLst/>
@@ -3659,17 +3659,17 @@
         </p:nvSpPr>
         <p:spPr>
           <a:xfrm>
-            <a:off x="13561740" y="2388766"/>
-            <a:ext cx="1108993" cy="200471"/>
-          </a:xfrm>
-          <a:prstGeom prst="rect">
-            <a:avLst/>
-          </a:prstGeom>
-          <a:noFill/>
-          <a:ln/>
-        </p:spPr>
-        <p:txBody>
-          <a:bodyPr wrap="square" lIns="25400" tIns="25400" rIns="25400" bIns="25400" rtlCol="0" anchor="ctr">
+            <a:off x="6780870" y="1194383"/>
+            <a:ext cx="554496" cy="100236"/>
+          </a:xfrm>
+          <a:prstGeom prst="rect">
+            <a:avLst/>
+          </a:prstGeom>
+          <a:noFill/>
+          <a:ln/>
+        </p:spPr>
+        <p:txBody>
+          <a:bodyPr wrap="square" lIns="12700" tIns="12700" rIns="12700" bIns="12700" rtlCol="0" anchor="ctr">
             <a:normAutofit/>
           </a:bodyPr>
           <a:lstStyle/>
@@ -3681,17 +3681,17 @@
               <a:buNone/>
             </a:pPr>
             <a:r>
-              <a:rPr lang="en-US" sz="975" b="1" kern="0" spc="78" dirty="0">
+              <a:rPr lang="en-US" sz="488" b="1" kern="0" spc="39" dirty="0">
                 <a:solidFill>
                   <a:srgbClr val="6A7285"/>
                 </a:solidFill>
-                <a:latin typeface="-apple-system" pitchFamily="34" charset="0"/>
-                <a:ea typeface="-apple-system" pitchFamily="34" charset="-122"/>
-                <a:cs typeface="-apple-system" pitchFamily="34" charset="-120"/>
+                <a:latin typeface="Arial" pitchFamily="34" charset="0"/>
+                <a:ea typeface="Arial" pitchFamily="34" charset="-122"/>
+                <a:cs typeface="Arial" pitchFamily="34" charset="-120"/>
               </a:rPr>
               <a:t>ЦЕНА</a:t>
             </a:r>
-            <a:endParaRPr lang="en-US" sz="975" dirty="0"/>
+            <a:endParaRPr lang="en-US" sz="488" dirty="0"/>
           </a:p>
         </p:txBody>
       </p:sp>
@@ -3703,8 +3703,8 @@
         </p:nvSpPr>
         <p:spPr>
           <a:xfrm>
-            <a:off x="14746932" y="2646387"/>
-            <a:ext cx="910382" cy="9525"/>
+            <a:off x="7373466" y="1323194"/>
+            <a:ext cx="455191" cy="4762"/>
           </a:xfrm>
           <a:prstGeom prst="rect">
             <a:avLst/>
@@ -3723,17 +3723,17 @@
         </p:nvSpPr>
         <p:spPr>
           <a:xfrm>
-            <a:off x="14746932" y="2388766"/>
-            <a:ext cx="834182" cy="200471"/>
-          </a:xfrm>
-          <a:prstGeom prst="rect">
-            <a:avLst/>
-          </a:prstGeom>
-          <a:noFill/>
-          <a:ln/>
-        </p:spPr>
-        <p:txBody>
-          <a:bodyPr wrap="square" lIns="25400" tIns="25400" rIns="25400" bIns="25400" rtlCol="0" anchor="ctr">
+            <a:off x="7373466" y="1194383"/>
+            <a:ext cx="417091" cy="100236"/>
+          </a:xfrm>
+          <a:prstGeom prst="rect">
+            <a:avLst/>
+          </a:prstGeom>
+          <a:noFill/>
+          <a:ln/>
+        </p:spPr>
+        <p:txBody>
+          <a:bodyPr wrap="square" lIns="12700" tIns="12700" rIns="12700" bIns="12700" rtlCol="0" anchor="ctr">
             <a:normAutofit/>
           </a:bodyPr>
           <a:lstStyle/>
@@ -3745,17 +3745,17 @@
               <a:buNone/>
             </a:pPr>
             <a:r>
-              <a:rPr lang="en-US" sz="975" b="1" kern="0" spc="78" dirty="0">
+              <a:rPr lang="en-US" sz="488" b="1" kern="0" spc="39" dirty="0">
                 <a:solidFill>
                   <a:srgbClr val="6A7285"/>
                 </a:solidFill>
-                <a:latin typeface="-apple-system" pitchFamily="34" charset="0"/>
-                <a:ea typeface="-apple-system" pitchFamily="34" charset="-122"/>
-                <a:cs typeface="-apple-system" pitchFamily="34" charset="-120"/>
+                <a:latin typeface="Arial" pitchFamily="34" charset="0"/>
+                <a:ea typeface="Arial" pitchFamily="34" charset="-122"/>
+                <a:cs typeface="Arial" pitchFamily="34" charset="-120"/>
               </a:rPr>
               <a:t>СКИДКА</a:t>
             </a:r>
-            <a:endParaRPr lang="en-US" sz="975" dirty="0"/>
+            <a:endParaRPr lang="en-US" sz="488" dirty="0"/>
           </a:p>
         </p:txBody>
       </p:sp>
@@ -3767,8 +3767,8 @@
         </p:nvSpPr>
         <p:spPr>
           <a:xfrm>
-            <a:off x="15657314" y="2646387"/>
-            <a:ext cx="1373386" cy="9525"/>
+            <a:off x="7828657" y="1323194"/>
+            <a:ext cx="686693" cy="4762"/>
           </a:xfrm>
           <a:prstGeom prst="rect">
             <a:avLst/>
@@ -3787,17 +3787,17 @@
         </p:nvSpPr>
         <p:spPr>
           <a:xfrm>
-            <a:off x="15657314" y="2388766"/>
-            <a:ext cx="1297186" cy="200471"/>
-          </a:xfrm>
-          <a:prstGeom prst="rect">
-            <a:avLst/>
-          </a:prstGeom>
-          <a:noFill/>
-          <a:ln/>
-        </p:spPr>
-        <p:txBody>
-          <a:bodyPr wrap="square" lIns="25400" tIns="25400" rIns="25400" bIns="25400" rtlCol="0" anchor="ctr">
+            <a:off x="7828657" y="1194383"/>
+            <a:ext cx="648593" cy="100236"/>
+          </a:xfrm>
+          <a:prstGeom prst="rect">
+            <a:avLst/>
+          </a:prstGeom>
+          <a:noFill/>
+          <a:ln/>
+        </p:spPr>
+        <p:txBody>
+          <a:bodyPr wrap="square" lIns="12700" tIns="12700" rIns="12700" bIns="12700" rtlCol="0" anchor="ctr">
             <a:normAutofit/>
           </a:bodyPr>
           <a:lstStyle/>
@@ -3809,17 +3809,17 @@
               <a:buNone/>
             </a:pPr>
             <a:r>
-              <a:rPr lang="en-US" sz="975" b="1" kern="0" spc="78" dirty="0">
+              <a:rPr lang="en-US" sz="488" b="1" kern="0" spc="39" dirty="0">
                 <a:solidFill>
                   <a:srgbClr val="6A7285"/>
                 </a:solidFill>
-                <a:latin typeface="-apple-system" pitchFamily="34" charset="0"/>
-                <a:ea typeface="-apple-system" pitchFamily="34" charset="-122"/>
-                <a:cs typeface="-apple-system" pitchFamily="34" charset="-120"/>
+                <a:latin typeface="Arial" pitchFamily="34" charset="0"/>
+                <a:ea typeface="Arial" pitchFamily="34" charset="-122"/>
+                <a:cs typeface="Arial" pitchFamily="34" charset="-120"/>
               </a:rPr>
               <a:t>СУММА</a:t>
             </a:r>
-            <a:endParaRPr lang="en-US" sz="975" dirty="0"/>
+            <a:endParaRPr lang="en-US" sz="488" dirty="0"/>
           </a:p>
         </p:txBody>
       </p:sp>
@@ -3831,17 +3831,17 @@
         </p:nvSpPr>
         <p:spPr>
           <a:xfrm>
-            <a:off x="9629775" y="2760687"/>
-            <a:ext cx="3236218" cy="261417"/>
-          </a:xfrm>
-          <a:prstGeom prst="rect">
-            <a:avLst/>
-          </a:prstGeom>
-          <a:noFill/>
-          <a:ln/>
-        </p:spPr>
-        <p:txBody>
-          <a:bodyPr wrap="square" lIns="25400" tIns="25400" rIns="25400" bIns="25400" rtlCol="0" anchor="ctr">
+            <a:off x="4814888" y="1380344"/>
+            <a:ext cx="1618109" cy="130708"/>
+          </a:xfrm>
+          <a:prstGeom prst="rect">
+            <a:avLst/>
+          </a:prstGeom>
+          <a:noFill/>
+          <a:ln/>
+        </p:spPr>
+        <p:txBody>
+          <a:bodyPr wrap="square" lIns="12700" tIns="12700" rIns="12700" bIns="12700" rtlCol="0" anchor="ctr">
             <a:normAutofit/>
           </a:bodyPr>
           <a:lstStyle/>
@@ -3853,17 +3853,17 @@
               <a:buNone/>
             </a:pPr>
             <a:r>
-              <a:rPr lang="en-US" sz="1275" b="1" dirty="0">
+              <a:rPr lang="en-US" sz="638" b="1" dirty="0">
                 <a:solidFill>
                   <a:srgbClr val="0B1F3A"/>
                 </a:solidFill>
-                <a:latin typeface="-apple-system" pitchFamily="34" charset="0"/>
-                <a:ea typeface="-apple-system" pitchFamily="34" charset="-122"/>
-                <a:cs typeface="-apple-system" pitchFamily="34" charset="-120"/>
+                <a:latin typeface="Arial" pitchFamily="34" charset="0"/>
+                <a:ea typeface="Arial" pitchFamily="34" charset="-122"/>
+                <a:cs typeface="Arial" pitchFamily="34" charset="-120"/>
               </a:rPr>
               <a:t>inno Kiosk × 5 устр. (1 месяц)</a:t>
             </a:r>
-            <a:endParaRPr lang="en-US" sz="1275" dirty="0"/>
+            <a:endParaRPr lang="en-US" sz="638" dirty="0"/>
           </a:p>
         </p:txBody>
       </p:sp>
@@ -3875,17 +3875,17 @@
         </p:nvSpPr>
         <p:spPr>
           <a:xfrm>
-            <a:off x="12843495" y="2760687"/>
-            <a:ext cx="642045" cy="261417"/>
-          </a:xfrm>
-          <a:prstGeom prst="rect">
-            <a:avLst/>
-          </a:prstGeom>
-          <a:noFill/>
-          <a:ln/>
-        </p:spPr>
-        <p:txBody>
-          <a:bodyPr wrap="square" lIns="25400" tIns="25400" rIns="25400" bIns="25400" rtlCol="0" anchor="ctr">
+            <a:off x="6421748" y="1380344"/>
+            <a:ext cx="321022" cy="130708"/>
+          </a:xfrm>
+          <a:prstGeom prst="rect">
+            <a:avLst/>
+          </a:prstGeom>
+          <a:noFill/>
+          <a:ln/>
+        </p:spPr>
+        <p:txBody>
+          <a:bodyPr wrap="square" lIns="12700" tIns="12700" rIns="12700" bIns="12700" rtlCol="0" anchor="ctr">
             <a:normAutofit/>
           </a:bodyPr>
           <a:lstStyle/>
@@ -3897,7 +3897,7 @@
               <a:buNone/>
             </a:pPr>
             <a:r>
-              <a:rPr lang="en-US" sz="1163" kern="0" spc="-12" dirty="0">
+              <a:rPr lang="en-US" sz="582" kern="0" spc="-6" dirty="0">
                 <a:solidFill>
                   <a:srgbClr val="29334A"/>
                 </a:solidFill>
@@ -3907,7 +3907,7 @@
               </a:rPr>
               <a:t>5</a:t>
             </a:r>
-            <a:endParaRPr lang="en-US" sz="1163" dirty="0"/>
+            <a:endParaRPr lang="en-US" sz="582" dirty="0"/>
           </a:p>
         </p:txBody>
       </p:sp>
@@ -3919,17 +3919,17 @@
         </p:nvSpPr>
         <p:spPr>
           <a:xfrm>
-            <a:off x="13561740" y="2760687"/>
-            <a:ext cx="1108993" cy="261417"/>
-          </a:xfrm>
-          <a:prstGeom prst="rect">
-            <a:avLst/>
-          </a:prstGeom>
-          <a:noFill/>
-          <a:ln/>
-        </p:spPr>
-        <p:txBody>
-          <a:bodyPr wrap="square" lIns="25400" tIns="25400" rIns="25400" bIns="25400" rtlCol="0" anchor="ctr">
+            <a:off x="6780870" y="1380344"/>
+            <a:ext cx="554496" cy="130708"/>
+          </a:xfrm>
+          <a:prstGeom prst="rect">
+            <a:avLst/>
+          </a:prstGeom>
+          <a:noFill/>
+          <a:ln/>
+        </p:spPr>
+        <p:txBody>
+          <a:bodyPr wrap="square" lIns="12700" tIns="12700" rIns="12700" bIns="12700" rtlCol="0" anchor="ctr">
             <a:normAutofit/>
           </a:bodyPr>
           <a:lstStyle/>
@@ -3941,7 +3941,7 @@
               <a:buNone/>
             </a:pPr>
             <a:r>
-              <a:rPr lang="en-US" sz="1163" kern="0" spc="-12" dirty="0">
+              <a:rPr lang="en-US" sz="582" kern="0" spc="-6" dirty="0">
                 <a:solidFill>
                   <a:srgbClr val="29334A"/>
                 </a:solidFill>
@@ -3951,7 +3951,7 @@
               </a:rPr>
               <a:t>10 000</a:t>
             </a:r>
-            <a:endParaRPr lang="en-US" sz="1163" dirty="0"/>
+            <a:endParaRPr lang="en-US" sz="582" dirty="0"/>
           </a:p>
         </p:txBody>
       </p:sp>
@@ -3963,17 +3963,17 @@
         </p:nvSpPr>
         <p:spPr>
           <a:xfrm>
-            <a:off x="14746932" y="2760687"/>
-            <a:ext cx="834182" cy="261417"/>
-          </a:xfrm>
-          <a:prstGeom prst="rect">
-            <a:avLst/>
-          </a:prstGeom>
-          <a:noFill/>
-          <a:ln/>
-        </p:spPr>
-        <p:txBody>
-          <a:bodyPr wrap="square" lIns="25400" tIns="25400" rIns="25400" bIns="25400" rtlCol="0" anchor="ctr">
+            <a:off x="7373466" y="1380344"/>
+            <a:ext cx="417091" cy="130708"/>
+          </a:xfrm>
+          <a:prstGeom prst="rect">
+            <a:avLst/>
+          </a:prstGeom>
+          <a:noFill/>
+          <a:ln/>
+        </p:spPr>
+        <p:txBody>
+          <a:bodyPr wrap="square" lIns="12700" tIns="12700" rIns="12700" bIns="12700" rtlCol="0" anchor="ctr">
             <a:normAutofit/>
           </a:bodyPr>
           <a:lstStyle/>
@@ -3985,7 +3985,7 @@
               <a:buNone/>
             </a:pPr>
             <a:r>
-              <a:rPr lang="en-US" sz="1163" kern="0" spc="-12" dirty="0">
+              <a:rPr lang="en-US" sz="582" kern="0" spc="-6" dirty="0">
                 <a:solidFill>
                   <a:srgbClr val="B8BEC9"/>
                 </a:solidFill>
@@ -3995,7 +3995,7 @@
               </a:rPr>
               <a:t>—</a:t>
             </a:r>
-            <a:endParaRPr lang="en-US" sz="1163" dirty="0"/>
+            <a:endParaRPr lang="en-US" sz="582" dirty="0"/>
           </a:p>
         </p:txBody>
       </p:sp>
@@ -4007,17 +4007,17 @@
         </p:nvSpPr>
         <p:spPr>
           <a:xfrm>
-            <a:off x="15657314" y="2760687"/>
-            <a:ext cx="1297186" cy="261417"/>
-          </a:xfrm>
-          <a:prstGeom prst="rect">
-            <a:avLst/>
-          </a:prstGeom>
-          <a:noFill/>
-          <a:ln/>
-        </p:spPr>
-        <p:txBody>
-          <a:bodyPr wrap="square" lIns="25400" tIns="25400" rIns="25400" bIns="25400" rtlCol="0" anchor="ctr">
+            <a:off x="7828657" y="1380344"/>
+            <a:ext cx="648593" cy="130708"/>
+          </a:xfrm>
+          <a:prstGeom prst="rect">
+            <a:avLst/>
+          </a:prstGeom>
+          <a:noFill/>
+          <a:ln/>
+        </p:spPr>
+        <p:txBody>
+          <a:bodyPr wrap="square" lIns="12700" tIns="12700" rIns="12700" bIns="12700" rtlCol="0" anchor="ctr">
             <a:normAutofit/>
           </a:bodyPr>
           <a:lstStyle/>
@@ -4029,7 +4029,7 @@
               <a:buNone/>
             </a:pPr>
             <a:r>
-              <a:rPr lang="en-US" sz="1163" b="1" kern="0" spc="-12" dirty="0">
+              <a:rPr lang="en-US" sz="582" b="1" kern="0" spc="-6" dirty="0">
                 <a:solidFill>
                   <a:srgbClr val="0B1F3A"/>
                 </a:solidFill>
@@ -4039,7 +4039,7 @@
               </a:rPr>
               <a:t>50 000</a:t>
             </a:r>
-            <a:endParaRPr lang="en-US" sz="1163" dirty="0"/>
+            <a:endParaRPr lang="en-US" sz="582" dirty="0"/>
           </a:p>
         </p:txBody>
       </p:sp>
@@ -4051,8 +4051,8 @@
         </p:nvSpPr>
         <p:spPr>
           <a:xfrm>
-            <a:off x="9553575" y="3222129"/>
-            <a:ext cx="7477125" cy="19050"/>
+            <a:off x="4776788" y="1611064"/>
+            <a:ext cx="3738562" cy="9525"/>
           </a:xfrm>
           <a:prstGeom prst="rect">
             <a:avLst/>
@@ -4071,18 +4071,18 @@
         </p:nvSpPr>
         <p:spPr>
           <a:xfrm>
-            <a:off x="9553575" y="3441204"/>
-            <a:ext cx="625227" cy="219075"/>
-          </a:xfrm>
-          <a:prstGeom prst="rect">
-            <a:avLst/>
-          </a:prstGeom>
-          <a:noFill/>
-          <a:ln/>
-        </p:spPr>
-        <p:txBody>
-          <a:bodyPr wrap="square" lIns="25400" tIns="25400" rIns="25400" bIns="25400" rtlCol="0" anchor="t">
-            <a:normAutofit/>
+            <a:off x="4776788" y="1720602"/>
+            <a:ext cx="500000" cy="109538"/>
+          </a:xfrm>
+          <a:prstGeom prst="rect">
+            <a:avLst/>
+          </a:prstGeom>
+          <a:noFill/>
+          <a:ln/>
+        </p:spPr>
+        <p:txBody>
+          <a:bodyPr wrap="none" lIns="12700" tIns="12700" rIns="12700" bIns="12700" rtlCol="0" anchor="t">
+            <a:noAutofit/>
           </a:bodyPr>
           <a:lstStyle/>
           <a:p>
@@ -4090,17 +4090,17 @@
               <a:buNone/>
             </a:pPr>
             <a:r>
-              <a:rPr lang="en-US" sz="1200" b="1" kern="0" spc="24" dirty="0">
+              <a:rPr lang="en-US" sz="600" b="1" kern="0" spc="12" dirty="0">
                 <a:solidFill>
                   <a:srgbClr val="0B1F3A"/>
                 </a:solidFill>
-                <a:latin typeface="-apple-system" pitchFamily="34" charset="0"/>
-                <a:ea typeface="-apple-system" pitchFamily="34" charset="-122"/>
-                <a:cs typeface="-apple-system" pitchFamily="34" charset="-120"/>
+                <a:latin typeface="Arial" pitchFamily="34" charset="0"/>
+                <a:ea typeface="Arial" pitchFamily="34" charset="-122"/>
+                <a:cs typeface="Arial" pitchFamily="34" charset="-120"/>
               </a:rPr>
               <a:t>ИТОГО</a:t>
             </a:r>
-            <a:endParaRPr lang="en-US" sz="1200" dirty="0"/>
+            <a:endParaRPr lang="en-US" sz="600" dirty="0"/>
           </a:p>
         </p:txBody>
       </p:sp>
@@ -4112,17 +4112,17 @@
         </p:nvSpPr>
         <p:spPr>
           <a:xfrm>
-            <a:off x="16024845" y="3374529"/>
-            <a:ext cx="1082055" cy="314325"/>
-          </a:xfrm>
-          <a:prstGeom prst="rect">
-            <a:avLst/>
-          </a:prstGeom>
-          <a:noFill/>
-          <a:ln/>
-        </p:spPr>
-        <p:txBody>
-          <a:bodyPr wrap="square" lIns="25400" tIns="25400" rIns="25400" bIns="25400" rtlCol="0" anchor="t">
+            <a:off x="8012422" y="1687264"/>
+            <a:ext cx="541028" cy="157162"/>
+          </a:xfrm>
+          <a:prstGeom prst="rect">
+            <a:avLst/>
+          </a:prstGeom>
+          <a:noFill/>
+          <a:ln/>
+        </p:spPr>
+        <p:txBody>
+          <a:bodyPr wrap="square" lIns="12700" tIns="12700" rIns="12700" bIns="12700" rtlCol="0" anchor="t">
             <a:normAutofit/>
           </a:bodyPr>
           <a:lstStyle/>
@@ -4131,7 +4131,7 @@
               <a:buNone/>
             </a:pPr>
             <a:r>
-              <a:rPr lang="en-US" sz="1650" b="1" dirty="0">
+              <a:rPr lang="en-US" sz="825" b="1" dirty="0">
                 <a:solidFill>
                   <a:srgbClr val="0B1F3A"/>
                 </a:solidFill>
@@ -4141,7 +4141,7 @@
               </a:rPr>
               <a:t>50 000 ₽</a:t>
             </a:r>
-            <a:endParaRPr lang="en-US" sz="1650" dirty="0"/>
+            <a:endParaRPr lang="en-US" sz="825" dirty="0"/>
           </a:p>
         </p:txBody>
       </p:sp>
@@ -4153,8 +4153,8 @@
         </p:nvSpPr>
         <p:spPr>
           <a:xfrm>
-            <a:off x="9248775" y="4847481"/>
-            <a:ext cx="8086725" cy="3391644"/>
+            <a:off x="4624388" y="2423740"/>
+            <a:ext cx="4043362" cy="1695822"/>
           </a:xfrm>
           <a:prstGeom prst="roundRect">
             <a:avLst>
@@ -4182,17 +4182,17 @@
         </p:nvSpPr>
         <p:spPr>
           <a:xfrm>
-            <a:off x="9553575" y="5095131"/>
-            <a:ext cx="7701439" cy="304800"/>
-          </a:xfrm>
-          <a:prstGeom prst="rect">
-            <a:avLst/>
-          </a:prstGeom>
-          <a:noFill/>
-          <a:ln/>
-        </p:spPr>
-        <p:txBody>
-          <a:bodyPr wrap="square" lIns="25400" tIns="25400" rIns="25400" bIns="25400" rtlCol="0" anchor="ctr">
+            <a:off x="4776788" y="2547566"/>
+            <a:ext cx="3850720" cy="152400"/>
+          </a:xfrm>
+          <a:prstGeom prst="rect">
+            <a:avLst/>
+          </a:prstGeom>
+          <a:noFill/>
+          <a:ln/>
+        </p:spPr>
+        <p:txBody>
+          <a:bodyPr wrap="square" lIns="12700" tIns="12700" rIns="12700" bIns="12700" rtlCol="0" anchor="ctr">
             <a:normAutofit/>
           </a:bodyPr>
           <a:lstStyle/>
@@ -4201,17 +4201,17 @@
               <a:buNone/>
             </a:pPr>
             <a:r>
-              <a:rPr lang="en-US" sz="1800" b="1" kern="0" spc="-9" dirty="0">
+              <a:rPr lang="en-US" sz="900" b="1" kern="0" spc="-4" dirty="0">
                 <a:solidFill>
                   <a:srgbClr val="0B1F3A"/>
                 </a:solidFill>
-                <a:latin typeface="-apple-system" pitchFamily="34" charset="0"/>
-                <a:ea typeface="-apple-system" pitchFamily="34" charset="-122"/>
-                <a:cs typeface="-apple-system" pitchFamily="34" charset="-120"/>
+                <a:latin typeface="Arial" pitchFamily="34" charset="0"/>
+                <a:ea typeface="Arial" pitchFamily="34" charset="-122"/>
+                <a:cs typeface="Arial" pitchFamily="34" charset="-120"/>
               </a:rPr>
               <a:t>Услуги</a:t>
             </a:r>
-            <a:endParaRPr lang="en-US" sz="1800" dirty="0"/>
+            <a:endParaRPr lang="en-US" sz="900" dirty="0"/>
           </a:p>
         </p:txBody>
       </p:sp>
@@ -4223,8 +4223,8 @@
         </p:nvSpPr>
         <p:spPr>
           <a:xfrm>
-            <a:off x="9553575" y="5809952"/>
-            <a:ext cx="3289920" cy="9525"/>
+            <a:off x="4776788" y="2904976"/>
+            <a:ext cx="1644960" cy="4762"/>
           </a:xfrm>
           <a:prstGeom prst="rect">
             <a:avLst/>
@@ -4243,17 +4243,17 @@
         </p:nvSpPr>
         <p:spPr>
           <a:xfrm>
-            <a:off x="9629775" y="5552331"/>
-            <a:ext cx="3236218" cy="200471"/>
-          </a:xfrm>
-          <a:prstGeom prst="rect">
-            <a:avLst/>
-          </a:prstGeom>
-          <a:noFill/>
-          <a:ln/>
-        </p:spPr>
-        <p:txBody>
-          <a:bodyPr wrap="square" lIns="25400" tIns="25400" rIns="25400" bIns="25400" rtlCol="0" anchor="ctr">
+            <a:off x="4814888" y="2776166"/>
+            <a:ext cx="1618109" cy="100236"/>
+          </a:xfrm>
+          <a:prstGeom prst="rect">
+            <a:avLst/>
+          </a:prstGeom>
+          <a:noFill/>
+          <a:ln/>
+        </p:spPr>
+        <p:txBody>
+          <a:bodyPr wrap="square" lIns="12700" tIns="12700" rIns="12700" bIns="12700" rtlCol="0" anchor="ctr">
             <a:normAutofit/>
           </a:bodyPr>
           <a:lstStyle/>
@@ -4265,17 +4265,17 @@
               <a:buNone/>
             </a:pPr>
             <a:r>
-              <a:rPr lang="en-US" sz="975" b="1" kern="0" spc="78" dirty="0">
+              <a:rPr lang="en-US" sz="488" b="1" kern="0" spc="39" dirty="0">
                 <a:solidFill>
                   <a:srgbClr val="6A7285"/>
                 </a:solidFill>
-                <a:latin typeface="-apple-system" pitchFamily="34" charset="0"/>
-                <a:ea typeface="-apple-system" pitchFamily="34" charset="-122"/>
-                <a:cs typeface="-apple-system" pitchFamily="34" charset="-120"/>
+                <a:latin typeface="Arial" pitchFamily="34" charset="0"/>
+                <a:ea typeface="Arial" pitchFamily="34" charset="-122"/>
+                <a:cs typeface="Arial" pitchFamily="34" charset="-120"/>
               </a:rPr>
               <a:t>НАИМЕНОВАНИЕ</a:t>
             </a:r>
-            <a:endParaRPr lang="en-US" sz="975" dirty="0"/>
+            <a:endParaRPr lang="en-US" sz="488" dirty="0"/>
           </a:p>
         </p:txBody>
       </p:sp>
@@ -4287,8 +4287,8 @@
         </p:nvSpPr>
         <p:spPr>
           <a:xfrm>
-            <a:off x="12843495" y="5809952"/>
-            <a:ext cx="718245" cy="9525"/>
+            <a:off x="6421748" y="2904976"/>
+            <a:ext cx="359122" cy="4762"/>
           </a:xfrm>
           <a:prstGeom prst="rect">
             <a:avLst/>
@@ -4307,17 +4307,17 @@
         </p:nvSpPr>
         <p:spPr>
           <a:xfrm>
-            <a:off x="12843495" y="5552331"/>
-            <a:ext cx="642045" cy="200471"/>
-          </a:xfrm>
-          <a:prstGeom prst="rect">
-            <a:avLst/>
-          </a:prstGeom>
-          <a:noFill/>
-          <a:ln/>
-        </p:spPr>
-        <p:txBody>
-          <a:bodyPr wrap="square" lIns="25400" tIns="25400" rIns="25400" bIns="25400" rtlCol="0" anchor="ctr">
+            <a:off x="6421748" y="2776166"/>
+            <a:ext cx="321022" cy="100236"/>
+          </a:xfrm>
+          <a:prstGeom prst="rect">
+            <a:avLst/>
+          </a:prstGeom>
+          <a:noFill/>
+          <a:ln/>
+        </p:spPr>
+        <p:txBody>
+          <a:bodyPr wrap="square" lIns="12700" tIns="12700" rIns="12700" bIns="12700" rtlCol="0" anchor="ctr">
             <a:normAutofit/>
           </a:bodyPr>
           <a:lstStyle/>
@@ -4329,17 +4329,17 @@
               <a:buNone/>
             </a:pPr>
             <a:r>
-              <a:rPr lang="en-US" sz="975" b="1" kern="0" spc="78" dirty="0">
+              <a:rPr lang="en-US" sz="488" b="1" kern="0" spc="39" dirty="0">
                 <a:solidFill>
                   <a:srgbClr val="6A7285"/>
                 </a:solidFill>
-                <a:latin typeface="-apple-system" pitchFamily="34" charset="0"/>
-                <a:ea typeface="-apple-system" pitchFamily="34" charset="-122"/>
-                <a:cs typeface="-apple-system" pitchFamily="34" charset="-120"/>
+                <a:latin typeface="Arial" pitchFamily="34" charset="0"/>
+                <a:ea typeface="Arial" pitchFamily="34" charset="-122"/>
+                <a:cs typeface="Arial" pitchFamily="34" charset="-120"/>
               </a:rPr>
               <a:t>КОЛ.</a:t>
             </a:r>
-            <a:endParaRPr lang="en-US" sz="975" dirty="0"/>
+            <a:endParaRPr lang="en-US" sz="488" dirty="0"/>
           </a:p>
         </p:txBody>
       </p:sp>
@@ -4351,8 +4351,8 @@
         </p:nvSpPr>
         <p:spPr>
           <a:xfrm>
-            <a:off x="13561740" y="5809952"/>
-            <a:ext cx="1185193" cy="9525"/>
+            <a:off x="6780870" y="2904976"/>
+            <a:ext cx="592596" cy="4762"/>
           </a:xfrm>
           <a:prstGeom prst="rect">
             <a:avLst/>
@@ -4371,17 +4371,17 @@
         </p:nvSpPr>
         <p:spPr>
           <a:xfrm>
-            <a:off x="13561740" y="5552331"/>
-            <a:ext cx="1108993" cy="200471"/>
-          </a:xfrm>
-          <a:prstGeom prst="rect">
-            <a:avLst/>
-          </a:prstGeom>
-          <a:noFill/>
-          <a:ln/>
-        </p:spPr>
-        <p:txBody>
-          <a:bodyPr wrap="square" lIns="25400" tIns="25400" rIns="25400" bIns="25400" rtlCol="0" anchor="ctr">
+            <a:off x="6780870" y="2776166"/>
+            <a:ext cx="554496" cy="100236"/>
+          </a:xfrm>
+          <a:prstGeom prst="rect">
+            <a:avLst/>
+          </a:prstGeom>
+          <a:noFill/>
+          <a:ln/>
+        </p:spPr>
+        <p:txBody>
+          <a:bodyPr wrap="square" lIns="12700" tIns="12700" rIns="12700" bIns="12700" rtlCol="0" anchor="ctr">
             <a:normAutofit/>
           </a:bodyPr>
           <a:lstStyle/>
@@ -4393,17 +4393,17 @@
               <a:buNone/>
             </a:pPr>
             <a:r>
-              <a:rPr lang="en-US" sz="975" b="1" kern="0" spc="78" dirty="0">
+              <a:rPr lang="en-US" sz="488" b="1" kern="0" spc="39" dirty="0">
                 <a:solidFill>
                   <a:srgbClr val="6A7285"/>
                 </a:solidFill>
-                <a:latin typeface="-apple-system" pitchFamily="34" charset="0"/>
-                <a:ea typeface="-apple-system" pitchFamily="34" charset="-122"/>
-                <a:cs typeface="-apple-system" pitchFamily="34" charset="-120"/>
+                <a:latin typeface="Arial" pitchFamily="34" charset="0"/>
+                <a:ea typeface="Arial" pitchFamily="34" charset="-122"/>
+                <a:cs typeface="Arial" pitchFamily="34" charset="-120"/>
               </a:rPr>
               <a:t>ЦЕНА</a:t>
             </a:r>
-            <a:endParaRPr lang="en-US" sz="975" dirty="0"/>
+            <a:endParaRPr lang="en-US" sz="488" dirty="0"/>
           </a:p>
         </p:txBody>
       </p:sp>
@@ -4415,8 +4415,8 @@
         </p:nvSpPr>
         <p:spPr>
           <a:xfrm>
-            <a:off x="14746932" y="5809952"/>
-            <a:ext cx="910382" cy="9525"/>
+            <a:off x="7373466" y="2904976"/>
+            <a:ext cx="455191" cy="4762"/>
           </a:xfrm>
           <a:prstGeom prst="rect">
             <a:avLst/>
@@ -4435,17 +4435,17 @@
         </p:nvSpPr>
         <p:spPr>
           <a:xfrm>
-            <a:off x="14746932" y="5552331"/>
-            <a:ext cx="834182" cy="200471"/>
-          </a:xfrm>
-          <a:prstGeom prst="rect">
-            <a:avLst/>
-          </a:prstGeom>
-          <a:noFill/>
-          <a:ln/>
-        </p:spPr>
-        <p:txBody>
-          <a:bodyPr wrap="square" lIns="25400" tIns="25400" rIns="25400" bIns="25400" rtlCol="0" anchor="ctr">
+            <a:off x="7373466" y="2776166"/>
+            <a:ext cx="417091" cy="100236"/>
+          </a:xfrm>
+          <a:prstGeom prst="rect">
+            <a:avLst/>
+          </a:prstGeom>
+          <a:noFill/>
+          <a:ln/>
+        </p:spPr>
+        <p:txBody>
+          <a:bodyPr wrap="square" lIns="12700" tIns="12700" rIns="12700" bIns="12700" rtlCol="0" anchor="ctr">
             <a:normAutofit/>
           </a:bodyPr>
           <a:lstStyle/>
@@ -4457,17 +4457,17 @@
               <a:buNone/>
             </a:pPr>
             <a:r>
-              <a:rPr lang="en-US" sz="975" b="1" kern="0" spc="78" dirty="0">
+              <a:rPr lang="en-US" sz="488" b="1" kern="0" spc="39" dirty="0">
                 <a:solidFill>
                   <a:srgbClr val="6A7285"/>
                 </a:solidFill>
-                <a:latin typeface="-apple-system" pitchFamily="34" charset="0"/>
-                <a:ea typeface="-apple-system" pitchFamily="34" charset="-122"/>
-                <a:cs typeface="-apple-system" pitchFamily="34" charset="-120"/>
+                <a:latin typeface="Arial" pitchFamily="34" charset="0"/>
+                <a:ea typeface="Arial" pitchFamily="34" charset="-122"/>
+                <a:cs typeface="Arial" pitchFamily="34" charset="-120"/>
               </a:rPr>
               <a:t>СКИДКА</a:t>
             </a:r>
-            <a:endParaRPr lang="en-US" sz="975" dirty="0"/>
+            <a:endParaRPr lang="en-US" sz="488" dirty="0"/>
           </a:p>
         </p:txBody>
       </p:sp>
@@ -4479,8 +4479,8 @@
         </p:nvSpPr>
         <p:spPr>
           <a:xfrm>
-            <a:off x="15657314" y="5809952"/>
-            <a:ext cx="1373386" cy="9525"/>
+            <a:off x="7828657" y="2904976"/>
+            <a:ext cx="686693" cy="4762"/>
           </a:xfrm>
           <a:prstGeom prst="rect">
             <a:avLst/>
@@ -4499,17 +4499,17 @@
         </p:nvSpPr>
         <p:spPr>
           <a:xfrm>
-            <a:off x="15657314" y="5552331"/>
-            <a:ext cx="1297186" cy="200471"/>
-          </a:xfrm>
-          <a:prstGeom prst="rect">
-            <a:avLst/>
-          </a:prstGeom>
-          <a:noFill/>
-          <a:ln/>
-        </p:spPr>
-        <p:txBody>
-          <a:bodyPr wrap="square" lIns="25400" tIns="25400" rIns="25400" bIns="25400" rtlCol="0" anchor="ctr">
+            <a:off x="7828657" y="2776166"/>
+            <a:ext cx="648593" cy="100236"/>
+          </a:xfrm>
+          <a:prstGeom prst="rect">
+            <a:avLst/>
+          </a:prstGeom>
+          <a:noFill/>
+          <a:ln/>
+        </p:spPr>
+        <p:txBody>
+          <a:bodyPr wrap="square" lIns="12700" tIns="12700" rIns="12700" bIns="12700" rtlCol="0" anchor="ctr">
             <a:normAutofit/>
           </a:bodyPr>
           <a:lstStyle/>
@@ -4521,17 +4521,17 @@
               <a:buNone/>
             </a:pPr>
             <a:r>
-              <a:rPr lang="en-US" sz="975" b="1" kern="0" spc="78" dirty="0">
+              <a:rPr lang="en-US" sz="488" b="1" kern="0" spc="39" dirty="0">
                 <a:solidFill>
                   <a:srgbClr val="6A7285"/>
                 </a:solidFill>
-                <a:latin typeface="-apple-system" pitchFamily="34" charset="0"/>
-                <a:ea typeface="-apple-system" pitchFamily="34" charset="-122"/>
-                <a:cs typeface="-apple-system" pitchFamily="34" charset="-120"/>
+                <a:latin typeface="Arial" pitchFamily="34" charset="0"/>
+                <a:ea typeface="Arial" pitchFamily="34" charset="-122"/>
+                <a:cs typeface="Arial" pitchFamily="34" charset="-120"/>
               </a:rPr>
               <a:t>СУММА</a:t>
             </a:r>
-            <a:endParaRPr lang="en-US" sz="975" dirty="0"/>
+            <a:endParaRPr lang="en-US" sz="488" dirty="0"/>
           </a:p>
         </p:txBody>
       </p:sp>
@@ -4543,8 +4543,8 @@
         </p:nvSpPr>
         <p:spPr>
           <a:xfrm>
-            <a:off x="9553575" y="6247581"/>
-            <a:ext cx="3289920" cy="9525"/>
+            <a:off x="4776788" y="3123790"/>
+            <a:ext cx="1644960" cy="4762"/>
           </a:xfrm>
           <a:prstGeom prst="rect">
             <a:avLst/>
@@ -4563,17 +4563,17 @@
         </p:nvSpPr>
         <p:spPr>
           <a:xfrm>
-            <a:off x="9629775" y="5924252"/>
-            <a:ext cx="3236218" cy="256654"/>
-          </a:xfrm>
-          <a:prstGeom prst="rect">
-            <a:avLst/>
-          </a:prstGeom>
-          <a:noFill/>
-          <a:ln/>
-        </p:spPr>
-        <p:txBody>
-          <a:bodyPr wrap="square" lIns="25400" tIns="25400" rIns="25400" bIns="25400" rtlCol="0" anchor="ctr">
+            <a:off x="4814888" y="2962126"/>
+            <a:ext cx="1618109" cy="128327"/>
+          </a:xfrm>
+          <a:prstGeom prst="rect">
+            <a:avLst/>
+          </a:prstGeom>
+          <a:noFill/>
+          <a:ln/>
+        </p:spPr>
+        <p:txBody>
+          <a:bodyPr wrap="square" lIns="12700" tIns="12700" rIns="12700" bIns="12700" rtlCol="0" anchor="ctr">
             <a:normAutofit/>
           </a:bodyPr>
           <a:lstStyle/>
@@ -4585,17 +4585,17 @@
               <a:buNone/>
             </a:pPr>
             <a:r>
-              <a:rPr lang="en-US" sz="1275" b="1" dirty="0">
+              <a:rPr lang="en-US" sz="638" b="1" dirty="0">
                 <a:solidFill>
                   <a:srgbClr val="0B1F3A"/>
                 </a:solidFill>
-                <a:latin typeface="-apple-system" pitchFamily="34" charset="0"/>
-                <a:ea typeface="-apple-system" pitchFamily="34" charset="-122"/>
-                <a:cs typeface="-apple-system" pitchFamily="34" charset="-120"/>
+                <a:latin typeface="Arial" pitchFamily="34" charset="0"/>
+                <a:ea typeface="Arial" pitchFamily="34" charset="-122"/>
+                <a:cs typeface="Arial" pitchFamily="34" charset="-120"/>
               </a:rPr>
               <a:t>Внедрение и настройка</a:t>
             </a:r>
-            <a:endParaRPr lang="en-US" sz="1275" dirty="0"/>
+            <a:endParaRPr lang="en-US" sz="638" dirty="0"/>
           </a:p>
         </p:txBody>
       </p:sp>
@@ -4607,8 +4607,8 @@
         </p:nvSpPr>
         <p:spPr>
           <a:xfrm>
-            <a:off x="12843495" y="6247581"/>
-            <a:ext cx="718245" cy="9525"/>
+            <a:off x="6421748" y="3123790"/>
+            <a:ext cx="359122" cy="4762"/>
           </a:xfrm>
           <a:prstGeom prst="rect">
             <a:avLst/>
@@ -4627,17 +4627,17 @@
         </p:nvSpPr>
         <p:spPr>
           <a:xfrm>
-            <a:off x="12843495" y="5924252"/>
-            <a:ext cx="642045" cy="256654"/>
-          </a:xfrm>
-          <a:prstGeom prst="rect">
-            <a:avLst/>
-          </a:prstGeom>
-          <a:noFill/>
-          <a:ln/>
-        </p:spPr>
-        <p:txBody>
-          <a:bodyPr wrap="square" lIns="25400" tIns="25400" rIns="25400" bIns="25400" rtlCol="0" anchor="ctr">
+            <a:off x="6421748" y="2962126"/>
+            <a:ext cx="321022" cy="128327"/>
+          </a:xfrm>
+          <a:prstGeom prst="rect">
+            <a:avLst/>
+          </a:prstGeom>
+          <a:noFill/>
+          <a:ln/>
+        </p:spPr>
+        <p:txBody>
+          <a:bodyPr wrap="square" lIns="12700" tIns="12700" rIns="12700" bIns="12700" rtlCol="0" anchor="ctr">
             <a:normAutofit/>
           </a:bodyPr>
           <a:lstStyle/>
@@ -4649,7 +4649,7 @@
               <a:buNone/>
             </a:pPr>
             <a:r>
-              <a:rPr lang="en-US" sz="1163" kern="0" spc="-12" dirty="0">
+              <a:rPr lang="en-US" sz="582" kern="0" spc="-6" dirty="0">
                 <a:solidFill>
                   <a:srgbClr val="29334A"/>
                 </a:solidFill>
@@ -4659,7 +4659,7 @@
               </a:rPr>
               <a:t>1</a:t>
             </a:r>
-            <a:endParaRPr lang="en-US" sz="1163" dirty="0"/>
+            <a:endParaRPr lang="en-US" sz="582" dirty="0"/>
           </a:p>
         </p:txBody>
       </p:sp>
@@ -4671,8 +4671,8 @@
         </p:nvSpPr>
         <p:spPr>
           <a:xfrm>
-            <a:off x="13561740" y="6247581"/>
-            <a:ext cx="1185193" cy="9525"/>
+            <a:off x="6780870" y="3123790"/>
+            <a:ext cx="592596" cy="4762"/>
           </a:xfrm>
           <a:prstGeom prst="rect">
             <a:avLst/>
@@ -4691,17 +4691,17 @@
         </p:nvSpPr>
         <p:spPr>
           <a:xfrm>
-            <a:off x="13561740" y="5924252"/>
-            <a:ext cx="1108993" cy="256654"/>
-          </a:xfrm>
-          <a:prstGeom prst="rect">
-            <a:avLst/>
-          </a:prstGeom>
-          <a:noFill/>
-          <a:ln/>
-        </p:spPr>
-        <p:txBody>
-          <a:bodyPr wrap="square" lIns="25400" tIns="25400" rIns="25400" bIns="25400" rtlCol="0" anchor="ctr">
+            <a:off x="6780870" y="2962126"/>
+            <a:ext cx="554496" cy="128327"/>
+          </a:xfrm>
+          <a:prstGeom prst="rect">
+            <a:avLst/>
+          </a:prstGeom>
+          <a:noFill/>
+          <a:ln/>
+        </p:spPr>
+        <p:txBody>
+          <a:bodyPr wrap="square" lIns="12700" tIns="12700" rIns="12700" bIns="12700" rtlCol="0" anchor="ctr">
             <a:normAutofit/>
           </a:bodyPr>
           <a:lstStyle/>
@@ -4713,7 +4713,7 @@
               <a:buNone/>
             </a:pPr>
             <a:r>
-              <a:rPr lang="en-US" sz="1163" kern="0" spc="-12" dirty="0">
+              <a:rPr lang="en-US" sz="582" kern="0" spc="-6" dirty="0">
                 <a:solidFill>
                   <a:srgbClr val="29334A"/>
                 </a:solidFill>
@@ -4723,7 +4723,7 @@
               </a:rPr>
               <a:t>60 000</a:t>
             </a:r>
-            <a:endParaRPr lang="en-US" sz="1163" dirty="0"/>
+            <a:endParaRPr lang="en-US" sz="582" dirty="0"/>
           </a:p>
         </p:txBody>
       </p:sp>
@@ -4735,8 +4735,8 @@
         </p:nvSpPr>
         <p:spPr>
           <a:xfrm>
-            <a:off x="14746932" y="6247581"/>
-            <a:ext cx="910382" cy="9525"/>
+            <a:off x="7373466" y="3123790"/>
+            <a:ext cx="455191" cy="4762"/>
           </a:xfrm>
           <a:prstGeom prst="rect">
             <a:avLst/>
@@ -4755,17 +4755,17 @@
         </p:nvSpPr>
         <p:spPr>
           <a:xfrm>
-            <a:off x="14746932" y="5924252"/>
-            <a:ext cx="834182" cy="256654"/>
-          </a:xfrm>
-          <a:prstGeom prst="rect">
-            <a:avLst/>
-          </a:prstGeom>
-          <a:noFill/>
-          <a:ln/>
-        </p:spPr>
-        <p:txBody>
-          <a:bodyPr wrap="square" lIns="25400" tIns="25400" rIns="25400" bIns="25400" rtlCol="0" anchor="ctr">
+            <a:off x="7373466" y="2962126"/>
+            <a:ext cx="417091" cy="128327"/>
+          </a:xfrm>
+          <a:prstGeom prst="rect">
+            <a:avLst/>
+          </a:prstGeom>
+          <a:noFill/>
+          <a:ln/>
+        </p:spPr>
+        <p:txBody>
+          <a:bodyPr wrap="square" lIns="12700" tIns="12700" rIns="12700" bIns="12700" rtlCol="0" anchor="ctr">
             <a:normAutofit/>
           </a:bodyPr>
           <a:lstStyle/>
@@ -4777,7 +4777,7 @@
               <a:buNone/>
             </a:pPr>
             <a:r>
-              <a:rPr lang="en-US" sz="1163" b="1" kern="0" spc="-12" dirty="0">
+              <a:rPr lang="en-US" sz="582" b="1" kern="0" spc="-6" dirty="0">
                 <a:solidFill>
                   <a:srgbClr val="FF6A1A"/>
                 </a:solidFill>
@@ -4787,7 +4787,7 @@
               </a:rPr>
               <a:t>-20%</a:t>
             </a:r>
-            <a:endParaRPr lang="en-US" sz="1163" dirty="0"/>
+            <a:endParaRPr lang="en-US" sz="582" dirty="0"/>
           </a:p>
         </p:txBody>
       </p:sp>
@@ -4799,8 +4799,8 @@
         </p:nvSpPr>
         <p:spPr>
           <a:xfrm>
-            <a:off x="15657314" y="6247581"/>
-            <a:ext cx="1373386" cy="9525"/>
+            <a:off x="7828657" y="3123790"/>
+            <a:ext cx="686693" cy="4762"/>
           </a:xfrm>
           <a:prstGeom prst="rect">
             <a:avLst/>
@@ -4819,17 +4819,17 @@
         </p:nvSpPr>
         <p:spPr>
           <a:xfrm>
-            <a:off x="15657314" y="5924252"/>
-            <a:ext cx="1297186" cy="256654"/>
-          </a:xfrm>
-          <a:prstGeom prst="rect">
-            <a:avLst/>
-          </a:prstGeom>
-          <a:noFill/>
-          <a:ln/>
-        </p:spPr>
-        <p:txBody>
-          <a:bodyPr wrap="square" lIns="25400" tIns="25400" rIns="25400" bIns="25400" rtlCol="0" anchor="ctr">
+            <a:off x="7828657" y="2962126"/>
+            <a:ext cx="648593" cy="128327"/>
+          </a:xfrm>
+          <a:prstGeom prst="rect">
+            <a:avLst/>
+          </a:prstGeom>
+          <a:noFill/>
+          <a:ln/>
+        </p:spPr>
+        <p:txBody>
+          <a:bodyPr wrap="square" lIns="12700" tIns="12700" rIns="12700" bIns="12700" rtlCol="0" anchor="ctr">
             <a:normAutofit/>
           </a:bodyPr>
           <a:lstStyle/>
@@ -4841,7 +4841,7 @@
               <a:buNone/>
             </a:pPr>
             <a:r>
-              <a:rPr lang="en-US" sz="1163" b="1" kern="0" spc="-12" dirty="0">
+              <a:rPr lang="en-US" sz="582" b="1" kern="0" spc="-6" dirty="0">
                 <a:solidFill>
                   <a:srgbClr val="0B1F3A"/>
                 </a:solidFill>
@@ -4851,7 +4851,7 @@
               </a:rPr>
               <a:t>48 000</a:t>
             </a:r>
-            <a:endParaRPr lang="en-US" sz="1163" dirty="0"/>
+            <a:endParaRPr lang="en-US" sz="582" dirty="0"/>
           </a:p>
         </p:txBody>
       </p:sp>
@@ -4863,17 +4863,17 @@
         </p:nvSpPr>
         <p:spPr>
           <a:xfrm>
-            <a:off x="9629775" y="6361881"/>
-            <a:ext cx="3236218" cy="261417"/>
-          </a:xfrm>
-          <a:prstGeom prst="rect">
-            <a:avLst/>
-          </a:prstGeom>
-          <a:noFill/>
-          <a:ln/>
-        </p:spPr>
-        <p:txBody>
-          <a:bodyPr wrap="square" lIns="25400" tIns="25400" rIns="25400" bIns="25400" rtlCol="0" anchor="ctr">
+            <a:off x="4814888" y="3180940"/>
+            <a:ext cx="1618109" cy="130708"/>
+          </a:xfrm>
+          <a:prstGeom prst="rect">
+            <a:avLst/>
+          </a:prstGeom>
+          <a:noFill/>
+          <a:ln/>
+        </p:spPr>
+        <p:txBody>
+          <a:bodyPr wrap="square" lIns="12700" tIns="12700" rIns="12700" bIns="12700" rtlCol="0" anchor="ctr">
             <a:normAutofit/>
           </a:bodyPr>
           <a:lstStyle/>
@@ -4885,17 +4885,17 @@
               <a:buNone/>
             </a:pPr>
             <a:r>
-              <a:rPr lang="en-US" sz="1275" b="1" dirty="0">
+              <a:rPr lang="en-US" sz="638" b="1" dirty="0">
                 <a:solidFill>
                   <a:srgbClr val="0B1F3A"/>
                 </a:solidFill>
-                <a:latin typeface="-apple-system" pitchFamily="34" charset="0"/>
-                <a:ea typeface="-apple-system" pitchFamily="34" charset="-122"/>
-                <a:cs typeface="-apple-system" pitchFamily="34" charset="-120"/>
+                <a:latin typeface="Arial" pitchFamily="34" charset="0"/>
+                <a:ea typeface="Arial" pitchFamily="34" charset="-122"/>
+                <a:cs typeface="Arial" pitchFamily="34" charset="-120"/>
               </a:rPr>
               <a:t>Генерация контента (карточки меню)</a:t>
             </a:r>
-            <a:endParaRPr lang="en-US" sz="1275" dirty="0"/>
+            <a:endParaRPr lang="en-US" sz="638" dirty="0"/>
           </a:p>
         </p:txBody>
       </p:sp>
@@ -4907,17 +4907,17 @@
         </p:nvSpPr>
         <p:spPr>
           <a:xfrm>
-            <a:off x="12843495" y="6361881"/>
-            <a:ext cx="642045" cy="261417"/>
-          </a:xfrm>
-          <a:prstGeom prst="rect">
-            <a:avLst/>
-          </a:prstGeom>
-          <a:noFill/>
-          <a:ln/>
-        </p:spPr>
-        <p:txBody>
-          <a:bodyPr wrap="square" lIns="25400" tIns="25400" rIns="25400" bIns="25400" rtlCol="0" anchor="ctr">
+            <a:off x="6421748" y="3180940"/>
+            <a:ext cx="321022" cy="130708"/>
+          </a:xfrm>
+          <a:prstGeom prst="rect">
+            <a:avLst/>
+          </a:prstGeom>
+          <a:noFill/>
+          <a:ln/>
+        </p:spPr>
+        <p:txBody>
+          <a:bodyPr wrap="square" lIns="12700" tIns="12700" rIns="12700" bIns="12700" rtlCol="0" anchor="ctr">
             <a:normAutofit/>
           </a:bodyPr>
           <a:lstStyle/>
@@ -4929,7 +4929,7 @@
               <a:buNone/>
             </a:pPr>
             <a:r>
-              <a:rPr lang="en-US" sz="1163" kern="0" spc="-12" dirty="0">
+              <a:rPr lang="en-US" sz="582" kern="0" spc="-6" dirty="0">
                 <a:solidFill>
                   <a:srgbClr val="29334A"/>
                 </a:solidFill>
@@ -4939,7 +4939,7 @@
               </a:rPr>
               <a:t>50</a:t>
             </a:r>
-            <a:endParaRPr lang="en-US" sz="1163" dirty="0"/>
+            <a:endParaRPr lang="en-US" sz="582" dirty="0"/>
           </a:p>
         </p:txBody>
       </p:sp>
@@ -4951,17 +4951,17 @@
         </p:nvSpPr>
         <p:spPr>
           <a:xfrm>
-            <a:off x="13561740" y="6361881"/>
-            <a:ext cx="1108993" cy="261417"/>
-          </a:xfrm>
-          <a:prstGeom prst="rect">
-            <a:avLst/>
-          </a:prstGeom>
-          <a:noFill/>
-          <a:ln/>
-        </p:spPr>
-        <p:txBody>
-          <a:bodyPr wrap="square" lIns="25400" tIns="25400" rIns="25400" bIns="25400" rtlCol="0" anchor="ctr">
+            <a:off x="6780870" y="3180940"/>
+            <a:ext cx="554496" cy="130708"/>
+          </a:xfrm>
+          <a:prstGeom prst="rect">
+            <a:avLst/>
+          </a:prstGeom>
+          <a:noFill/>
+          <a:ln/>
+        </p:spPr>
+        <p:txBody>
+          <a:bodyPr wrap="square" lIns="12700" tIns="12700" rIns="12700" bIns="12700" rtlCol="0" anchor="ctr">
             <a:normAutofit/>
           </a:bodyPr>
           <a:lstStyle/>
@@ -4973,7 +4973,7 @@
               <a:buNone/>
             </a:pPr>
             <a:r>
-              <a:rPr lang="en-US" sz="1163" kern="0" spc="-12" dirty="0">
+              <a:rPr lang="en-US" sz="582" kern="0" spc="-6" dirty="0">
                 <a:solidFill>
                   <a:srgbClr val="29334A"/>
                 </a:solidFill>
@@ -4983,7 +4983,7 @@
               </a:rPr>
               <a:t>1 200</a:t>
             </a:r>
-            <a:endParaRPr lang="en-US" sz="1163" dirty="0"/>
+            <a:endParaRPr lang="en-US" sz="582" dirty="0"/>
           </a:p>
         </p:txBody>
       </p:sp>
@@ -4995,17 +4995,17 @@
         </p:nvSpPr>
         <p:spPr>
           <a:xfrm>
-            <a:off x="14746932" y="6361881"/>
-            <a:ext cx="834182" cy="261417"/>
-          </a:xfrm>
-          <a:prstGeom prst="rect">
-            <a:avLst/>
-          </a:prstGeom>
-          <a:noFill/>
-          <a:ln/>
-        </p:spPr>
-        <p:txBody>
-          <a:bodyPr wrap="square" lIns="25400" tIns="25400" rIns="25400" bIns="25400" rtlCol="0" anchor="ctr">
+            <a:off x="7373466" y="3180940"/>
+            <a:ext cx="417091" cy="130708"/>
+          </a:xfrm>
+          <a:prstGeom prst="rect">
+            <a:avLst/>
+          </a:prstGeom>
+          <a:noFill/>
+          <a:ln/>
+        </p:spPr>
+        <p:txBody>
+          <a:bodyPr wrap="square" lIns="12700" tIns="12700" rIns="12700" bIns="12700" rtlCol="0" anchor="ctr">
             <a:normAutofit/>
           </a:bodyPr>
           <a:lstStyle/>
@@ -5017,7 +5017,7 @@
               <a:buNone/>
             </a:pPr>
             <a:r>
-              <a:rPr lang="en-US" sz="1163" b="1" kern="0" spc="-12" dirty="0">
+              <a:rPr lang="en-US" sz="582" b="1" kern="0" spc="-6" dirty="0">
                 <a:solidFill>
                   <a:srgbClr val="FF6A1A"/>
                 </a:solidFill>
@@ -5027,7 +5027,7 @@
               </a:rPr>
               <a:t>-20%</a:t>
             </a:r>
-            <a:endParaRPr lang="en-US" sz="1163" dirty="0"/>
+            <a:endParaRPr lang="en-US" sz="582" dirty="0"/>
           </a:p>
         </p:txBody>
       </p:sp>
@@ -5039,17 +5039,17 @@
         </p:nvSpPr>
         <p:spPr>
           <a:xfrm>
-            <a:off x="15657314" y="6361881"/>
-            <a:ext cx="1297186" cy="261417"/>
-          </a:xfrm>
-          <a:prstGeom prst="rect">
-            <a:avLst/>
-          </a:prstGeom>
-          <a:noFill/>
-          <a:ln/>
-        </p:spPr>
-        <p:txBody>
-          <a:bodyPr wrap="square" lIns="25400" tIns="25400" rIns="25400" bIns="25400" rtlCol="0" anchor="ctr">
+            <a:off x="7828657" y="3180940"/>
+            <a:ext cx="648593" cy="130708"/>
+          </a:xfrm>
+          <a:prstGeom prst="rect">
+            <a:avLst/>
+          </a:prstGeom>
+          <a:noFill/>
+          <a:ln/>
+        </p:spPr>
+        <p:txBody>
+          <a:bodyPr wrap="square" lIns="12700" tIns="12700" rIns="12700" bIns="12700" rtlCol="0" anchor="ctr">
             <a:normAutofit/>
           </a:bodyPr>
           <a:lstStyle/>
@@ -5061,7 +5061,7 @@
               <a:buNone/>
             </a:pPr>
             <a:r>
-              <a:rPr lang="en-US" sz="1163" b="1" kern="0" spc="-12" dirty="0">
+              <a:rPr lang="en-US" sz="582" b="1" kern="0" spc="-6" dirty="0">
                 <a:solidFill>
                   <a:srgbClr val="0B1F3A"/>
                 </a:solidFill>
@@ -5071,7 +5071,7 @@
               </a:rPr>
               <a:t>48 000</a:t>
             </a:r>
-            <a:endParaRPr lang="en-US" sz="1163" dirty="0"/>
+            <a:endParaRPr lang="en-US" sz="582" dirty="0"/>
           </a:p>
         </p:txBody>
       </p:sp>
@@ -5083,8 +5083,8 @@
         </p:nvSpPr>
         <p:spPr>
           <a:xfrm>
-            <a:off x="9553575" y="6823323"/>
-            <a:ext cx="7477125" cy="19050"/>
+            <a:off x="4776788" y="3411662"/>
+            <a:ext cx="3738562" cy="9525"/>
           </a:xfrm>
           <a:prstGeom prst="rect">
             <a:avLst/>
@@ -5103,18 +5103,18 @@
         </p:nvSpPr>
         <p:spPr>
           <a:xfrm>
-            <a:off x="9553575" y="7042398"/>
-            <a:ext cx="625227" cy="219075"/>
-          </a:xfrm>
-          <a:prstGeom prst="rect">
-            <a:avLst/>
-          </a:prstGeom>
-          <a:noFill/>
-          <a:ln/>
-        </p:spPr>
-        <p:txBody>
-          <a:bodyPr wrap="square" lIns="25400" tIns="25400" rIns="25400" bIns="25400" rtlCol="0" anchor="t">
-            <a:normAutofit/>
+            <a:off x="4776788" y="3521199"/>
+            <a:ext cx="500000" cy="109538"/>
+          </a:xfrm>
+          <a:prstGeom prst="rect">
+            <a:avLst/>
+          </a:prstGeom>
+          <a:noFill/>
+          <a:ln/>
+        </p:spPr>
+        <p:txBody>
+          <a:bodyPr wrap="none" lIns="12700" tIns="12700" rIns="12700" bIns="12700" rtlCol="0" anchor="t">
+            <a:noAutofit/>
           </a:bodyPr>
           <a:lstStyle/>
           <a:p>
@@ -5122,17 +5122,17 @@
               <a:buNone/>
             </a:pPr>
             <a:r>
-              <a:rPr lang="en-US" sz="1200" b="1" kern="0" spc="24" dirty="0">
+              <a:rPr lang="en-US" sz="600" b="1" kern="0" spc="12" dirty="0">
                 <a:solidFill>
                   <a:srgbClr val="0B1F3A"/>
                 </a:solidFill>
-                <a:latin typeface="-apple-system" pitchFamily="34" charset="0"/>
-                <a:ea typeface="-apple-system" pitchFamily="34" charset="-122"/>
-                <a:cs typeface="-apple-system" pitchFamily="34" charset="-120"/>
+                <a:latin typeface="Arial" pitchFamily="34" charset="0"/>
+                <a:ea typeface="Arial" pitchFamily="34" charset="-122"/>
+                <a:cs typeface="Arial" pitchFamily="34" charset="-120"/>
               </a:rPr>
               <a:t>ИТОГО</a:t>
             </a:r>
-            <a:endParaRPr lang="en-US" sz="1200" dirty="0"/>
+            <a:endParaRPr lang="en-US" sz="600" dirty="0"/>
           </a:p>
         </p:txBody>
       </p:sp>
@@ -5144,17 +5144,17 @@
         </p:nvSpPr>
         <p:spPr>
           <a:xfrm>
-            <a:off x="16024845" y="6975723"/>
-            <a:ext cx="1082055" cy="314325"/>
-          </a:xfrm>
-          <a:prstGeom prst="rect">
-            <a:avLst/>
-          </a:prstGeom>
-          <a:noFill/>
-          <a:ln/>
-        </p:spPr>
-        <p:txBody>
-          <a:bodyPr wrap="square" lIns="25400" tIns="25400" rIns="25400" bIns="25400" rtlCol="0" anchor="t">
+            <a:off x="8012422" y="3487862"/>
+            <a:ext cx="541028" cy="157162"/>
+          </a:xfrm>
+          <a:prstGeom prst="rect">
+            <a:avLst/>
+          </a:prstGeom>
+          <a:noFill/>
+          <a:ln/>
+        </p:spPr>
+        <p:txBody>
+          <a:bodyPr wrap="square" lIns="12700" tIns="12700" rIns="12700" bIns="12700" rtlCol="0" anchor="t">
             <a:normAutofit/>
           </a:bodyPr>
           <a:lstStyle/>
@@ -5163,7 +5163,7 @@
               <a:buNone/>
             </a:pPr>
             <a:r>
-              <a:rPr lang="en-US" sz="1650" b="1" dirty="0">
+              <a:rPr lang="en-US" sz="825" b="1" dirty="0">
                 <a:solidFill>
                   <a:srgbClr val="0B1F3A"/>
                 </a:solidFill>
@@ -5173,7 +5173,7 @@
               </a:rPr>
               <a:t>96 000 ₽</a:t>
             </a:r>
-            <a:endParaRPr lang="en-US" sz="1650" dirty="0"/>
+            <a:endParaRPr lang="en-US" sz="825" dirty="0"/>
           </a:p>
         </p:txBody>
       </p:sp>
@@ -5185,8 +5185,8 @@
         </p:nvSpPr>
         <p:spPr>
           <a:xfrm>
-            <a:off x="952500" y="8448675"/>
-            <a:ext cx="16383000" cy="1152525"/>
+            <a:off x="476250" y="4224338"/>
+            <a:ext cx="8191500" cy="576262"/>
           </a:xfrm>
           <a:prstGeom prst="roundRect">
             <a:avLst>
@@ -5214,18 +5214,18 @@
         </p:nvSpPr>
         <p:spPr>
           <a:xfrm>
-            <a:off x="1257300" y="8789194"/>
-            <a:ext cx="1416844" cy="171450"/>
-          </a:xfrm>
-          <a:prstGeom prst="rect">
-            <a:avLst/>
-          </a:prstGeom>
-          <a:noFill/>
-          <a:ln/>
-        </p:spPr>
-        <p:txBody>
-          <a:bodyPr wrap="square" lIns="25400" tIns="25400" rIns="25400" bIns="25400" rtlCol="0" anchor="t">
-            <a:normAutofit/>
+            <a:off x="628650" y="4394597"/>
+            <a:ext cx="1200000" cy="85725"/>
+          </a:xfrm>
+          <a:prstGeom prst="rect">
+            <a:avLst/>
+          </a:prstGeom>
+          <a:noFill/>
+          <a:ln/>
+        </p:spPr>
+        <p:txBody>
+          <a:bodyPr wrap="none" lIns="12700" tIns="12700" rIns="12700" bIns="12700" rtlCol="0" anchor="t">
+            <a:noAutofit/>
           </a:bodyPr>
           <a:lstStyle/>
           <a:p>
@@ -5233,19 +5233,19 @@
               <a:buNone/>
             </a:pPr>
             <a:r>
-              <a:rPr lang="en-US" sz="900" b="1" kern="0" spc="144" dirty="0">
+              <a:rPr lang="en-US" sz="450" b="1" kern="0" spc="72" dirty="0">
                 <a:solidFill>
                   <a:srgbClr val="FFFFFF">
                     <a:alpha val="55000"/>
                   </a:srgbClr>
                 </a:solidFill>
-                <a:latin typeface="-apple-system" pitchFamily="34" charset="0"/>
-                <a:ea typeface="-apple-system" pitchFamily="34" charset="-122"/>
-                <a:cs typeface="-apple-system" pitchFamily="34" charset="-120"/>
+                <a:latin typeface="Arial" pitchFamily="34" charset="0"/>
+                <a:ea typeface="Arial" pitchFamily="34" charset="-122"/>
+                <a:cs typeface="Arial" pitchFamily="34" charset="-120"/>
               </a:rPr>
               <a:t>ИТОГОВАЯ СМЕТА</a:t>
             </a:r>
-            <a:endParaRPr lang="en-US" sz="900" dirty="0"/>
+            <a:endParaRPr lang="en-US" sz="450" dirty="0"/>
           </a:p>
         </p:txBody>
       </p:sp>
@@ -5257,18 +5257,18 @@
         </p:nvSpPr>
         <p:spPr>
           <a:xfrm>
-            <a:off x="1257300" y="8922544"/>
-            <a:ext cx="1416844" cy="376238"/>
-          </a:xfrm>
-          <a:prstGeom prst="rect">
-            <a:avLst/>
-          </a:prstGeom>
-          <a:noFill/>
-          <a:ln/>
-        </p:spPr>
-        <p:txBody>
-          <a:bodyPr wrap="square" lIns="25400" tIns="25400" rIns="25400" bIns="25400" rtlCol="0" anchor="t">
-            <a:normAutofit/>
+            <a:off x="628650" y="4461272"/>
+            <a:ext cx="1200000" cy="188119"/>
+          </a:xfrm>
+          <a:prstGeom prst="rect">
+            <a:avLst/>
+          </a:prstGeom>
+          <a:noFill/>
+          <a:ln/>
+        </p:spPr>
+        <p:txBody>
+          <a:bodyPr wrap="none" lIns="12700" tIns="12700" rIns="12700" bIns="12700" rtlCol="0" anchor="t">
+            <a:noAutofit/>
           </a:bodyPr>
           <a:lstStyle/>
           <a:p>
@@ -5276,17 +5276,17 @@
               <a:buNone/>
             </a:pPr>
             <a:r>
-              <a:rPr lang="en-US" sz="2250" b="1" kern="0" spc="-11" dirty="0">
+              <a:rPr lang="en-US" sz="1125" b="1" kern="0" spc="-6" dirty="0">
                 <a:solidFill>
                   <a:srgbClr val="FFFFFF"/>
                 </a:solidFill>
-                <a:latin typeface="-apple-system" pitchFamily="34" charset="0"/>
-                <a:ea typeface="-apple-system" pitchFamily="34" charset="-122"/>
-                <a:cs typeface="-apple-system" pitchFamily="34" charset="-120"/>
+                <a:latin typeface="Arial" pitchFamily="34" charset="0"/>
+                <a:ea typeface="Arial" pitchFamily="34" charset="-122"/>
+                <a:cs typeface="Arial" pitchFamily="34" charset="-120"/>
               </a:rPr>
               <a:t>К оплате</a:t>
             </a:r>
-            <a:endParaRPr lang="en-US" sz="2250" dirty="0"/>
+            <a:endParaRPr lang="en-US" sz="1125" dirty="0"/>
           </a:p>
         </p:txBody>
       </p:sp>
@@ -5298,18 +5298,18 @@
         </p:nvSpPr>
         <p:spPr>
           <a:xfrm>
-            <a:off x="13892410" y="8658225"/>
-            <a:ext cx="3138290" cy="571500"/>
-          </a:xfrm>
-          <a:prstGeom prst="rect">
-            <a:avLst/>
-          </a:prstGeom>
-          <a:noFill/>
-          <a:ln/>
-        </p:spPr>
-        <p:txBody>
-          <a:bodyPr wrap="square" lIns="25400" tIns="25400" rIns="25400" bIns="25400" rtlCol="0" anchor="t">
-            <a:normAutofit/>
+            <a:off x="6946205" y="4329112"/>
+            <a:ext cx="1569145" cy="285750"/>
+          </a:xfrm>
+          <a:prstGeom prst="rect">
+            <a:avLst/>
+          </a:prstGeom>
+          <a:noFill/>
+          <a:ln/>
+        </p:spPr>
+        <p:txBody>
+          <a:bodyPr wrap="none" lIns="12700" tIns="12700" rIns="12700" bIns="12700" rtlCol="0" anchor="t">
+            <a:noAutofit/>
           </a:bodyPr>
           <a:lstStyle/>
           <a:p>
@@ -5320,28 +5320,28 @@
               <a:buNone/>
             </a:pPr>
             <a:r>
-              <a:rPr lang="en-US" sz="4200" b="1" kern="0" spc="-84" dirty="0">
+              <a:rPr lang="en-US" sz="2100" b="1" kern="0" spc="-42" dirty="0">
                 <a:solidFill>
                   <a:srgbClr val="FFFFFF"/>
                 </a:solidFill>
-                <a:latin typeface="-apple-system" pitchFamily="34" charset="0"/>
-                <a:ea typeface="-apple-system" pitchFamily="34" charset="-122"/>
-                <a:cs typeface="-apple-system" pitchFamily="34" charset="-120"/>
-              </a:rPr>
-              <a:t>1 013 400 </a:t>
-            </a:r>
-            <a:r>
-              <a:rPr lang="en-US" sz="4200" b="1" kern="0" spc="-84" dirty="0">
+                <a:latin typeface="Arial" pitchFamily="34" charset="0"/>
+                <a:ea typeface="Arial" pitchFamily="34" charset="-122"/>
+                <a:cs typeface="Arial" pitchFamily="34" charset="-120"/>
+              </a:rPr>
+              <a:t xml:space="preserve">1 013 400 </a:t>
+            </a:r>
+            <a:r>
+              <a:rPr lang="en-US" sz="2100" b="1" kern="0" spc="-42" dirty="0">
                 <a:solidFill>
                   <a:srgbClr val="FF6A1A"/>
                 </a:solidFill>
-                <a:latin typeface="-apple-system" pitchFamily="34" charset="0"/>
-                <a:ea typeface="-apple-system" pitchFamily="34" charset="-122"/>
-                <a:cs typeface="-apple-system" pitchFamily="34" charset="-120"/>
+                <a:latin typeface="Arial" pitchFamily="34" charset="0"/>
+                <a:ea typeface="Arial" pitchFamily="34" charset="-122"/>
+                <a:cs typeface="Arial" pitchFamily="34" charset="-120"/>
               </a:rPr>
               <a:t>₽</a:t>
             </a:r>
-            <a:endParaRPr lang="en-US" sz="4200" dirty="0"/>
+            <a:endParaRPr lang="en-US" sz="2100" dirty="0"/>
           </a:p>
         </p:txBody>
       </p:sp>
@@ -5353,17 +5353,17 @@
         </p:nvSpPr>
         <p:spPr>
           <a:xfrm>
-            <a:off x="13892410" y="9248775"/>
-            <a:ext cx="3138290" cy="180975"/>
-          </a:xfrm>
-          <a:prstGeom prst="rect">
-            <a:avLst/>
-          </a:prstGeom>
-          <a:noFill/>
-          <a:ln/>
-        </p:spPr>
-        <p:txBody>
-          <a:bodyPr wrap="square" lIns="25400" tIns="25400" rIns="25400" bIns="25400" rtlCol="0" anchor="t">
+            <a:off x="6946205" y="4624388"/>
+            <a:ext cx="1569145" cy="90488"/>
+          </a:xfrm>
+          <a:prstGeom prst="rect">
+            <a:avLst/>
+          </a:prstGeom>
+          <a:noFill/>
+          <a:ln/>
+        </p:spPr>
+        <p:txBody>
+          <a:bodyPr wrap="square" lIns="12700" tIns="12700" rIns="12700" bIns="12700" rtlCol="0" anchor="t">
             <a:normAutofit/>
           </a:bodyPr>
           <a:lstStyle/>
@@ -5372,19 +5372,19 @@
               <a:buNone/>
             </a:pPr>
             <a:r>
-              <a:rPr lang="en-US" sz="975" kern="0" spc="39" dirty="0">
+              <a:rPr lang="en-US" sz="488" kern="0" spc="20" dirty="0">
                 <a:solidFill>
                   <a:srgbClr val="FFFFFF">
                     <a:alpha val="50000"/>
                   </a:srgbClr>
                 </a:solidFill>
-                <a:latin typeface="-apple-system" pitchFamily="34" charset="0"/>
-                <a:ea typeface="-apple-system" pitchFamily="34" charset="-122"/>
-                <a:cs typeface="-apple-system" pitchFamily="34" charset="-120"/>
+                <a:latin typeface="Arial" pitchFamily="34" charset="0"/>
+                <a:ea typeface="Arial" pitchFamily="34" charset="-122"/>
+                <a:cs typeface="Arial" pitchFamily="34" charset="-120"/>
               </a:rPr>
               <a:t>Все цены указаны в рублях, с учётом скидок</a:t>
             </a:r>
-            <a:endParaRPr lang="en-US" sz="975" dirty="0"/>
+            <a:endParaRPr lang="en-US" sz="488" dirty="0"/>
           </a:p>
         </p:txBody>
       </p:sp>

</xml_diff>